<commit_message>
chore: sync local work + add freelance lead bot
</commit_message>
<xml_diff>
--- a/docs/startups-application/03_pitch_deck.pptx
+++ b/docs/startups-application/03_pitch_deck.pptx
@@ -5,18 +5,18 @@
     <p:sldMasterId id="2147483648" r:id="rId1"/>
   </p:sldMasterIdLst>
   <p:sldIdLst>
-    <p:sldId id="256" r:id="rId7"/>
-    <p:sldId id="257" r:id="rId8"/>
-    <p:sldId id="258" r:id="rId9"/>
-    <p:sldId id="259" r:id="rId10"/>
-    <p:sldId id="260" r:id="rId11"/>
-    <p:sldId id="261" r:id="rId12"/>
-    <p:sldId id="262" r:id="rId13"/>
-    <p:sldId id="263" r:id="rId14"/>
-    <p:sldId id="264" r:id="rId15"/>
-    <p:sldId id="265" r:id="rId16"/>
+    <p:sldId id="256" r:id="rId2"/>
+    <p:sldId id="257" r:id="rId3"/>
+    <p:sldId id="258" r:id="rId4"/>
+    <p:sldId id="259" r:id="rId5"/>
+    <p:sldId id="260" r:id="rId6"/>
+    <p:sldId id="261" r:id="rId7"/>
+    <p:sldId id="262" r:id="rId8"/>
+    <p:sldId id="263" r:id="rId9"/>
+    <p:sldId id="264" r:id="rId10"/>
+    <p:sldId id="265" r:id="rId11"/>
   </p:sldIdLst>
-  <p:sldSz cx="12191695" cy="6858000" type="screen4x3"/>
+  <p:sldSz cx="12192000" cy="6858000"/>
   <p:notesSz cx="6858000" cy="9144000"/>
   <p:defaultTextStyle>
     <a:defPPr>
@@ -113,6 +113,22 @@
       </a:defRPr>
     </a:lvl9pPr>
   </p:defaultTextStyle>
+  <p:extLst>
+    <p:ext uri="{EFAFB233-063F-42B5-8137-9DF3F51BA10A}">
+      <p15:sldGuideLst xmlns:p15="http://schemas.microsoft.com/office/powerpoint/2012/main">
+        <p15:guide id="1" orient="horz" pos="2160">
+          <p15:clr>
+            <a:srgbClr val="A4A3A4"/>
+          </p15:clr>
+        </p15:guide>
+        <p15:guide id="2" pos="2880">
+          <p15:clr>
+            <a:srgbClr val="A4A3A4"/>
+          </p15:clr>
+        </p15:guide>
+      </p15:sldGuideLst>
+    </p:ext>
+  </p:extLst>
 </p:presentation>
 </file>
 
@@ -154,10 +170,9 @@
           <a:lstStyle/>
           <a:p>
             <a:r>
-              <a:rPr lang="en-US" smtClean="0"/>
+              <a:rPr lang="en-US"/>
               <a:t>Click to edit Master title style</a:t>
             </a:r>
-            <a:endParaRPr lang="en-US"/>
           </a:p>
         </p:txBody>
       </p:sp>
@@ -273,10 +288,9 @@
           </a:lstStyle>
           <a:p>
             <a:r>
-              <a:rPr lang="en-US" smtClean="0"/>
+              <a:rPr lang="en-US"/>
               <a:t>Click to edit Master subtitle style</a:t>
             </a:r>
-            <a:endParaRPr lang="en-US"/>
           </a:p>
         </p:txBody>
       </p:sp>
@@ -297,7 +311,7 @@
           <a:p>
             <a:fld id="{5BCAD085-E8A6-8845-BD4E-CB4CCA059FC4}" type="datetimeFigureOut">
               <a:rPr lang="en-US" smtClean="0"/>
-              <a:t>1/27/13</a:t>
+              <a:t>5/29/2026</a:t>
             </a:fld>
             <a:endParaRPr lang="en-US"/>
           </a:p>
@@ -391,10 +405,9 @@
           <a:lstStyle/>
           <a:p>
             <a:r>
-              <a:rPr lang="en-US" smtClean="0"/>
+              <a:rPr lang="en-US"/>
               <a:t>Click to edit Master title style</a:t>
             </a:r>
-            <a:endParaRPr lang="en-US"/>
           </a:p>
         </p:txBody>
       </p:sp>
@@ -415,38 +428,37 @@
           <a:p>
             <a:pPr lvl="0"/>
             <a:r>
-              <a:rPr lang="en-US" smtClean="0"/>
+              <a:rPr lang="en-US"/>
               <a:t>Click to edit Master text styles</a:t>
             </a:r>
           </a:p>
           <a:p>
             <a:pPr lvl="1"/>
             <a:r>
-              <a:rPr lang="en-US" smtClean="0"/>
+              <a:rPr lang="en-US"/>
               <a:t>Second level</a:t>
             </a:r>
           </a:p>
           <a:p>
             <a:pPr lvl="2"/>
             <a:r>
-              <a:rPr lang="en-US" smtClean="0"/>
+              <a:rPr lang="en-US"/>
               <a:t>Third level</a:t>
             </a:r>
           </a:p>
           <a:p>
             <a:pPr lvl="3"/>
             <a:r>
-              <a:rPr lang="en-US" smtClean="0"/>
+              <a:rPr lang="en-US"/>
               <a:t>Fourth level</a:t>
             </a:r>
           </a:p>
           <a:p>
             <a:pPr lvl="4"/>
             <a:r>
-              <a:rPr lang="en-US" smtClean="0"/>
+              <a:rPr lang="en-US"/>
               <a:t>Fifth level</a:t>
             </a:r>
-            <a:endParaRPr lang="en-US"/>
           </a:p>
         </p:txBody>
       </p:sp>
@@ -467,7 +479,7 @@
           <a:p>
             <a:fld id="{5BCAD085-E8A6-8845-BD4E-CB4CCA059FC4}" type="datetimeFigureOut">
               <a:rPr lang="en-US" smtClean="0"/>
-              <a:t>1/27/13</a:t>
+              <a:t>5/29/2026</a:t>
             </a:fld>
             <a:endParaRPr lang="en-US"/>
           </a:p>
@@ -566,10 +578,9 @@
           <a:lstStyle/>
           <a:p>
             <a:r>
-              <a:rPr lang="en-US" smtClean="0"/>
+              <a:rPr lang="en-US"/>
               <a:t>Click to edit Master title style</a:t>
             </a:r>
-            <a:endParaRPr lang="en-US"/>
           </a:p>
         </p:txBody>
       </p:sp>
@@ -595,38 +606,37 @@
           <a:p>
             <a:pPr lvl="0"/>
             <a:r>
-              <a:rPr lang="en-US" smtClean="0"/>
+              <a:rPr lang="en-US"/>
               <a:t>Click to edit Master text styles</a:t>
             </a:r>
           </a:p>
           <a:p>
             <a:pPr lvl="1"/>
             <a:r>
-              <a:rPr lang="en-US" smtClean="0"/>
+              <a:rPr lang="en-US"/>
               <a:t>Second level</a:t>
             </a:r>
           </a:p>
           <a:p>
             <a:pPr lvl="2"/>
             <a:r>
-              <a:rPr lang="en-US" smtClean="0"/>
+              <a:rPr lang="en-US"/>
               <a:t>Third level</a:t>
             </a:r>
           </a:p>
           <a:p>
             <a:pPr lvl="3"/>
             <a:r>
-              <a:rPr lang="en-US" smtClean="0"/>
+              <a:rPr lang="en-US"/>
               <a:t>Fourth level</a:t>
             </a:r>
           </a:p>
           <a:p>
             <a:pPr lvl="4"/>
             <a:r>
-              <a:rPr lang="en-US" smtClean="0"/>
+              <a:rPr lang="en-US"/>
               <a:t>Fifth level</a:t>
             </a:r>
-            <a:endParaRPr lang="en-US"/>
           </a:p>
         </p:txBody>
       </p:sp>
@@ -647,7 +657,7 @@
           <a:p>
             <a:fld id="{5BCAD085-E8A6-8845-BD4E-CB4CCA059FC4}" type="datetimeFigureOut">
               <a:rPr lang="en-US" smtClean="0"/>
-              <a:t>1/27/13</a:t>
+              <a:t>5/29/2026</a:t>
             </a:fld>
             <a:endParaRPr lang="en-US"/>
           </a:p>
@@ -741,10 +751,9 @@
           <a:lstStyle/>
           <a:p>
             <a:r>
-              <a:rPr lang="en-US" smtClean="0"/>
+              <a:rPr lang="en-US"/>
               <a:t>Click to edit Master title style</a:t>
             </a:r>
-            <a:endParaRPr lang="en-US"/>
           </a:p>
         </p:txBody>
       </p:sp>
@@ -765,38 +774,37 @@
           <a:p>
             <a:pPr lvl="0"/>
             <a:r>
-              <a:rPr lang="en-US" smtClean="0"/>
+              <a:rPr lang="en-US"/>
               <a:t>Click to edit Master text styles</a:t>
             </a:r>
           </a:p>
           <a:p>
             <a:pPr lvl="1"/>
             <a:r>
-              <a:rPr lang="en-US" smtClean="0"/>
+              <a:rPr lang="en-US"/>
               <a:t>Second level</a:t>
             </a:r>
           </a:p>
           <a:p>
             <a:pPr lvl="2"/>
             <a:r>
-              <a:rPr lang="en-US" smtClean="0"/>
+              <a:rPr lang="en-US"/>
               <a:t>Third level</a:t>
             </a:r>
           </a:p>
           <a:p>
             <a:pPr lvl="3"/>
             <a:r>
-              <a:rPr lang="en-US" smtClean="0"/>
+              <a:rPr lang="en-US"/>
               <a:t>Fourth level</a:t>
             </a:r>
           </a:p>
           <a:p>
             <a:pPr lvl="4"/>
             <a:r>
-              <a:rPr lang="en-US" smtClean="0"/>
+              <a:rPr lang="en-US"/>
               <a:t>Fifth level</a:t>
             </a:r>
-            <a:endParaRPr lang="en-US"/>
           </a:p>
         </p:txBody>
       </p:sp>
@@ -817,7 +825,7 @@
           <a:p>
             <a:fld id="{5BCAD085-E8A6-8845-BD4E-CB4CCA059FC4}" type="datetimeFigureOut">
               <a:rPr lang="en-US" smtClean="0"/>
-              <a:t>1/27/13</a:t>
+              <a:t>5/29/2026</a:t>
             </a:fld>
             <a:endParaRPr lang="en-US"/>
           </a:p>
@@ -920,10 +928,9 @@
           </a:lstStyle>
           <a:p>
             <a:r>
-              <a:rPr lang="en-US" smtClean="0"/>
+              <a:rPr lang="en-US"/>
               <a:t>Click to edit Master title style</a:t>
             </a:r>
-            <a:endParaRPr lang="en-US"/>
           </a:p>
         </p:txBody>
       </p:sp>
@@ -1040,7 +1047,7 @@
           <a:p>
             <a:pPr lvl="0"/>
             <a:r>
-              <a:rPr lang="en-US" smtClean="0"/>
+              <a:rPr lang="en-US"/>
               <a:t>Click to edit Master text styles</a:t>
             </a:r>
           </a:p>
@@ -1063,7 +1070,7 @@
           <a:p>
             <a:fld id="{5BCAD085-E8A6-8845-BD4E-CB4CCA059FC4}" type="datetimeFigureOut">
               <a:rPr lang="en-US" smtClean="0"/>
-              <a:t>1/27/13</a:t>
+              <a:t>5/29/2026</a:t>
             </a:fld>
             <a:endParaRPr lang="en-US"/>
           </a:p>
@@ -1157,10 +1164,9 @@
           <a:lstStyle/>
           <a:p>
             <a:r>
-              <a:rPr lang="en-US" smtClean="0"/>
+              <a:rPr lang="en-US"/>
               <a:t>Click to edit Master title style</a:t>
             </a:r>
-            <a:endParaRPr lang="en-US"/>
           </a:p>
         </p:txBody>
       </p:sp>
@@ -1214,38 +1220,37 @@
           <a:p>
             <a:pPr lvl="0"/>
             <a:r>
-              <a:rPr lang="en-US" smtClean="0"/>
+              <a:rPr lang="en-US"/>
               <a:t>Click to edit Master text styles</a:t>
             </a:r>
           </a:p>
           <a:p>
             <a:pPr lvl="1"/>
             <a:r>
-              <a:rPr lang="en-US" smtClean="0"/>
+              <a:rPr lang="en-US"/>
               <a:t>Second level</a:t>
             </a:r>
           </a:p>
           <a:p>
             <a:pPr lvl="2"/>
             <a:r>
-              <a:rPr lang="en-US" smtClean="0"/>
+              <a:rPr lang="en-US"/>
               <a:t>Third level</a:t>
             </a:r>
           </a:p>
           <a:p>
             <a:pPr lvl="3"/>
             <a:r>
-              <a:rPr lang="en-US" smtClean="0"/>
+              <a:rPr lang="en-US"/>
               <a:t>Fourth level</a:t>
             </a:r>
           </a:p>
           <a:p>
             <a:pPr lvl="4"/>
             <a:r>
-              <a:rPr lang="en-US" smtClean="0"/>
+              <a:rPr lang="en-US"/>
               <a:t>Fifth level</a:t>
             </a:r>
-            <a:endParaRPr lang="en-US"/>
           </a:p>
         </p:txBody>
       </p:sp>
@@ -1299,38 +1304,37 @@
           <a:p>
             <a:pPr lvl="0"/>
             <a:r>
-              <a:rPr lang="en-US" smtClean="0"/>
+              <a:rPr lang="en-US"/>
               <a:t>Click to edit Master text styles</a:t>
             </a:r>
           </a:p>
           <a:p>
             <a:pPr lvl="1"/>
             <a:r>
-              <a:rPr lang="en-US" smtClean="0"/>
+              <a:rPr lang="en-US"/>
               <a:t>Second level</a:t>
             </a:r>
           </a:p>
           <a:p>
             <a:pPr lvl="2"/>
             <a:r>
-              <a:rPr lang="en-US" smtClean="0"/>
+              <a:rPr lang="en-US"/>
               <a:t>Third level</a:t>
             </a:r>
           </a:p>
           <a:p>
             <a:pPr lvl="3"/>
             <a:r>
-              <a:rPr lang="en-US" smtClean="0"/>
+              <a:rPr lang="en-US"/>
               <a:t>Fourth level</a:t>
             </a:r>
           </a:p>
           <a:p>
             <a:pPr lvl="4"/>
             <a:r>
-              <a:rPr lang="en-US" smtClean="0"/>
+              <a:rPr lang="en-US"/>
               <a:t>Fifth level</a:t>
             </a:r>
-            <a:endParaRPr lang="en-US"/>
           </a:p>
         </p:txBody>
       </p:sp>
@@ -1351,7 +1355,7 @@
           <a:p>
             <a:fld id="{5BCAD085-E8A6-8845-BD4E-CB4CCA059FC4}" type="datetimeFigureOut">
               <a:rPr lang="en-US" smtClean="0"/>
-              <a:t>1/27/13</a:t>
+              <a:t>5/29/2026</a:t>
             </a:fld>
             <a:endParaRPr lang="en-US"/>
           </a:p>
@@ -1449,10 +1453,9 @@
           </a:lstStyle>
           <a:p>
             <a:r>
-              <a:rPr lang="en-US" smtClean="0"/>
+              <a:rPr lang="en-US"/>
               <a:t>Click to edit Master title style</a:t>
             </a:r>
-            <a:endParaRPr lang="en-US"/>
           </a:p>
         </p:txBody>
       </p:sp>
@@ -1515,7 +1518,7 @@
           <a:p>
             <a:pPr lvl="0"/>
             <a:r>
-              <a:rPr lang="en-US" smtClean="0"/>
+              <a:rPr lang="en-US"/>
               <a:t>Click to edit Master text styles</a:t>
             </a:r>
           </a:p>
@@ -1571,38 +1574,37 @@
           <a:p>
             <a:pPr lvl="0"/>
             <a:r>
-              <a:rPr lang="en-US" smtClean="0"/>
+              <a:rPr lang="en-US"/>
               <a:t>Click to edit Master text styles</a:t>
             </a:r>
           </a:p>
           <a:p>
             <a:pPr lvl="1"/>
             <a:r>
-              <a:rPr lang="en-US" smtClean="0"/>
+              <a:rPr lang="en-US"/>
               <a:t>Second level</a:t>
             </a:r>
           </a:p>
           <a:p>
             <a:pPr lvl="2"/>
             <a:r>
-              <a:rPr lang="en-US" smtClean="0"/>
+              <a:rPr lang="en-US"/>
               <a:t>Third level</a:t>
             </a:r>
           </a:p>
           <a:p>
             <a:pPr lvl="3"/>
             <a:r>
-              <a:rPr lang="en-US" smtClean="0"/>
+              <a:rPr lang="en-US"/>
               <a:t>Fourth level</a:t>
             </a:r>
           </a:p>
           <a:p>
             <a:pPr lvl="4"/>
             <a:r>
-              <a:rPr lang="en-US" smtClean="0"/>
+              <a:rPr lang="en-US"/>
               <a:t>Fifth level</a:t>
             </a:r>
-            <a:endParaRPr lang="en-US"/>
           </a:p>
         </p:txBody>
       </p:sp>
@@ -1665,7 +1667,7 @@
           <a:p>
             <a:pPr lvl="0"/>
             <a:r>
-              <a:rPr lang="en-US" smtClean="0"/>
+              <a:rPr lang="en-US"/>
               <a:t>Click to edit Master text styles</a:t>
             </a:r>
           </a:p>
@@ -1721,38 +1723,37 @@
           <a:p>
             <a:pPr lvl="0"/>
             <a:r>
-              <a:rPr lang="en-US" smtClean="0"/>
+              <a:rPr lang="en-US"/>
               <a:t>Click to edit Master text styles</a:t>
             </a:r>
           </a:p>
           <a:p>
             <a:pPr lvl="1"/>
             <a:r>
-              <a:rPr lang="en-US" smtClean="0"/>
+              <a:rPr lang="en-US"/>
               <a:t>Second level</a:t>
             </a:r>
           </a:p>
           <a:p>
             <a:pPr lvl="2"/>
             <a:r>
-              <a:rPr lang="en-US" smtClean="0"/>
+              <a:rPr lang="en-US"/>
               <a:t>Third level</a:t>
             </a:r>
           </a:p>
           <a:p>
             <a:pPr lvl="3"/>
             <a:r>
-              <a:rPr lang="en-US" smtClean="0"/>
+              <a:rPr lang="en-US"/>
               <a:t>Fourth level</a:t>
             </a:r>
           </a:p>
           <a:p>
             <a:pPr lvl="4"/>
             <a:r>
-              <a:rPr lang="en-US" smtClean="0"/>
+              <a:rPr lang="en-US"/>
               <a:t>Fifth level</a:t>
             </a:r>
-            <a:endParaRPr lang="en-US"/>
           </a:p>
         </p:txBody>
       </p:sp>
@@ -1773,7 +1774,7 @@
           <a:p>
             <a:fld id="{5BCAD085-E8A6-8845-BD4E-CB4CCA059FC4}" type="datetimeFigureOut">
               <a:rPr lang="en-US" smtClean="0"/>
-              <a:t>1/27/13</a:t>
+              <a:t>5/29/2026</a:t>
             </a:fld>
             <a:endParaRPr lang="en-US"/>
           </a:p>
@@ -1867,10 +1868,9 @@
           <a:lstStyle/>
           <a:p>
             <a:r>
-              <a:rPr lang="en-US" smtClean="0"/>
+              <a:rPr lang="en-US"/>
               <a:t>Click to edit Master title style</a:t>
             </a:r>
-            <a:endParaRPr lang="en-US"/>
           </a:p>
         </p:txBody>
       </p:sp>
@@ -1891,7 +1891,7 @@
           <a:p>
             <a:fld id="{5BCAD085-E8A6-8845-BD4E-CB4CCA059FC4}" type="datetimeFigureOut">
               <a:rPr lang="en-US" smtClean="0"/>
-              <a:t>1/27/13</a:t>
+              <a:t>5/29/2026</a:t>
             </a:fld>
             <a:endParaRPr lang="en-US"/>
           </a:p>
@@ -1986,7 +1986,7 @@
           <a:p>
             <a:fld id="{5BCAD085-E8A6-8845-BD4E-CB4CCA059FC4}" type="datetimeFigureOut">
               <a:rPr lang="en-US" smtClean="0"/>
-              <a:t>1/27/13</a:t>
+              <a:t>5/29/2026</a:t>
             </a:fld>
             <a:endParaRPr lang="en-US"/>
           </a:p>
@@ -2089,10 +2089,9 @@
           </a:lstStyle>
           <a:p>
             <a:r>
-              <a:rPr lang="en-US" smtClean="0"/>
+              <a:rPr lang="en-US"/>
               <a:t>Click to edit Master title style</a:t>
             </a:r>
-            <a:endParaRPr lang="en-US"/>
           </a:p>
         </p:txBody>
       </p:sp>
@@ -2146,38 +2145,37 @@
           <a:p>
             <a:pPr lvl="0"/>
             <a:r>
-              <a:rPr lang="en-US" smtClean="0"/>
+              <a:rPr lang="en-US"/>
               <a:t>Click to edit Master text styles</a:t>
             </a:r>
           </a:p>
           <a:p>
             <a:pPr lvl="1"/>
             <a:r>
-              <a:rPr lang="en-US" smtClean="0"/>
+              <a:rPr lang="en-US"/>
               <a:t>Second level</a:t>
             </a:r>
           </a:p>
           <a:p>
             <a:pPr lvl="2"/>
             <a:r>
-              <a:rPr lang="en-US" smtClean="0"/>
+              <a:rPr lang="en-US"/>
               <a:t>Third level</a:t>
             </a:r>
           </a:p>
           <a:p>
             <a:pPr lvl="3"/>
             <a:r>
-              <a:rPr lang="en-US" smtClean="0"/>
+              <a:rPr lang="en-US"/>
               <a:t>Fourth level</a:t>
             </a:r>
           </a:p>
           <a:p>
             <a:pPr lvl="4"/>
             <a:r>
-              <a:rPr lang="en-US" smtClean="0"/>
+              <a:rPr lang="en-US"/>
               <a:t>Fifth level</a:t>
             </a:r>
-            <a:endParaRPr lang="en-US"/>
           </a:p>
         </p:txBody>
       </p:sp>
@@ -2240,7 +2238,7 @@
           <a:p>
             <a:pPr lvl="0"/>
             <a:r>
-              <a:rPr lang="en-US" smtClean="0"/>
+              <a:rPr lang="en-US"/>
               <a:t>Click to edit Master text styles</a:t>
             </a:r>
           </a:p>
@@ -2263,7 +2261,7 @@
           <a:p>
             <a:fld id="{5BCAD085-E8A6-8845-BD4E-CB4CCA059FC4}" type="datetimeFigureOut">
               <a:rPr lang="en-US" smtClean="0"/>
-              <a:t>1/27/13</a:t>
+              <a:t>5/29/2026</a:t>
             </a:fld>
             <a:endParaRPr lang="en-US"/>
           </a:p>
@@ -2366,10 +2364,9 @@
           </a:lstStyle>
           <a:p>
             <a:r>
-              <a:rPr lang="en-US" smtClean="0"/>
+              <a:rPr lang="en-US"/>
               <a:t>Click to edit Master title style</a:t>
             </a:r>
-            <a:endParaRPr lang="en-US"/>
           </a:p>
         </p:txBody>
       </p:sp>
@@ -2493,7 +2490,7 @@
           <a:p>
             <a:pPr lvl="0"/>
             <a:r>
-              <a:rPr lang="en-US" smtClean="0"/>
+              <a:rPr lang="en-US"/>
               <a:t>Click to edit Master text styles</a:t>
             </a:r>
           </a:p>
@@ -2516,7 +2513,7 @@
           <a:p>
             <a:fld id="{5BCAD085-E8A6-8845-BD4E-CB4CCA059FC4}" type="datetimeFigureOut">
               <a:rPr lang="en-US" smtClean="0"/>
-              <a:t>1/27/13</a:t>
+              <a:t>5/29/2026</a:t>
             </a:fld>
             <a:endParaRPr lang="en-US"/>
           </a:p>
@@ -2625,10 +2622,9 @@
           <a:lstStyle/>
           <a:p>
             <a:r>
-              <a:rPr lang="en-US" smtClean="0"/>
+              <a:rPr lang="en-US"/>
               <a:t>Click to edit Master title style</a:t>
             </a:r>
-            <a:endParaRPr lang="en-US"/>
           </a:p>
         </p:txBody>
       </p:sp>
@@ -2659,38 +2655,37 @@
           <a:p>
             <a:pPr lvl="0"/>
             <a:r>
-              <a:rPr lang="en-US" smtClean="0"/>
+              <a:rPr lang="en-US"/>
               <a:t>Click to edit Master text styles</a:t>
             </a:r>
           </a:p>
           <a:p>
             <a:pPr lvl="1"/>
             <a:r>
-              <a:rPr lang="en-US" smtClean="0"/>
+              <a:rPr lang="en-US"/>
               <a:t>Second level</a:t>
             </a:r>
           </a:p>
           <a:p>
             <a:pPr lvl="2"/>
             <a:r>
-              <a:rPr lang="en-US" smtClean="0"/>
+              <a:rPr lang="en-US"/>
               <a:t>Third level</a:t>
             </a:r>
           </a:p>
           <a:p>
             <a:pPr lvl="3"/>
             <a:r>
-              <a:rPr lang="en-US" smtClean="0"/>
+              <a:rPr lang="en-US"/>
               <a:t>Fourth level</a:t>
             </a:r>
           </a:p>
           <a:p>
             <a:pPr lvl="4"/>
             <a:r>
-              <a:rPr lang="en-US" smtClean="0"/>
+              <a:rPr lang="en-US"/>
               <a:t>Fifth level</a:t>
             </a:r>
-            <a:endParaRPr lang="en-US"/>
           </a:p>
         </p:txBody>
       </p:sp>
@@ -2729,7 +2724,7 @@
           <a:p>
             <a:fld id="{5BCAD085-E8A6-8845-BD4E-CB4CCA059FC4}" type="datetimeFigureOut">
               <a:rPr lang="en-US" smtClean="0"/>
-              <a:t>1/27/13</a:t>
+              <a:t>5/29/2026</a:t>
             </a:fld>
             <a:endParaRPr lang="en-US"/>
           </a:p>
@@ -3088,7 +3083,7 @@
 </file>
 
 <file path=ppt/slides/slide1.xml><?xml version="1.0" encoding="utf-8"?>
-<p:sld xmlns:a="http://schemas.openxmlformats.org/drawingml/2006/main" xmlns:p="http://schemas.openxmlformats.org/presentationml/2006/main" xmlns:r="http://schemas.openxmlformats.org/officeDocument/2006/relationships">
+<p:sld xmlns:a="http://schemas.openxmlformats.org/drawingml/2006/main" xmlns:r="http://schemas.openxmlformats.org/officeDocument/2006/relationships" xmlns:p="http://schemas.openxmlformats.org/presentationml/2006/main">
   <p:cSld>
     <p:spTree>
       <p:nvGrpSpPr>
@@ -3096,7 +3091,14 @@
         <p:cNvGrpSpPr/>
         <p:nvPr/>
       </p:nvGrpSpPr>
-      <p:grpSpPr/>
+      <p:grpSpPr>
+        <a:xfrm>
+          <a:off x="0" y="0"/>
+          <a:ext cx="0" cy="0"/>
+          <a:chOff x="0" y="0"/>
+          <a:chExt cx="0" cy="0"/>
+        </a:xfrm>
+      </p:grpSpPr>
       <p:sp>
         <p:nvSpPr>
           <p:cNvPr id="2" name="Rectangle 1"/>
@@ -3137,6 +3139,7 @@
           <a:lstStyle/>
           <a:p>
             <a:pPr algn="ctr"/>
+            <a:endParaRPr/>
           </a:p>
         </p:txBody>
       </p:sp>
@@ -3180,6 +3183,7 @@
           <a:lstStyle/>
           <a:p>
             <a:pPr algn="ctr"/>
+            <a:endParaRPr/>
           </a:p>
         </p:txBody>
       </p:sp>
@@ -3223,6 +3227,7 @@
           <a:lstStyle/>
           <a:p>
             <a:pPr algn="ctr"/>
+            <a:endParaRPr/>
           </a:p>
         </p:txBody>
       </p:sp>
@@ -3266,6 +3271,7 @@
           <a:lstStyle/>
           <a:p>
             <a:pPr algn="ctr"/>
+            <a:endParaRPr/>
           </a:p>
         </p:txBody>
       </p:sp>
@@ -3286,7 +3292,7 @@
           <a:noFill/>
         </p:spPr>
         <p:txBody>
-          <a:bodyPr wrap="square" lIns="0" rIns="0" tIns="0" bIns="0" anchor="ctr">
+          <a:bodyPr wrap="square" lIns="0" tIns="0" rIns="0" bIns="0" anchor="ctr">
             <a:spAutoFit/>
           </a:bodyPr>
           <a:lstStyle/>
@@ -3321,7 +3327,7 @@
           <a:noFill/>
         </p:spPr>
         <p:txBody>
-          <a:bodyPr wrap="square" lIns="0" rIns="0" tIns="0" bIns="0">
+          <a:bodyPr wrap="square" lIns="0" tIns="0" rIns="0" bIns="0">
             <a:spAutoFit/>
           </a:bodyPr>
           <a:lstStyle/>
@@ -3355,7 +3361,7 @@
           <a:noFill/>
         </p:spPr>
         <p:txBody>
-          <a:bodyPr wrap="square" lIns="0" rIns="0" tIns="0" bIns="0">
+          <a:bodyPr wrap="square" lIns="0" tIns="0" rIns="0" bIns="0">
             <a:spAutoFit/>
           </a:bodyPr>
           <a:lstStyle/>
@@ -3389,7 +3395,7 @@
           <a:noFill/>
         </p:spPr>
         <p:txBody>
-          <a:bodyPr wrap="square" lIns="0" rIns="0" tIns="0" bIns="0">
+          <a:bodyPr wrap="square" lIns="0" tIns="0" rIns="0" bIns="0">
             <a:spAutoFit/>
           </a:bodyPr>
           <a:lstStyle/>
@@ -3423,7 +3429,7 @@
           <a:noFill/>
         </p:spPr>
         <p:txBody>
-          <a:bodyPr wrap="square" lIns="0" rIns="0" tIns="0" bIns="0">
+          <a:bodyPr wrap="square" lIns="0" tIns="0" rIns="0" bIns="0">
             <a:spAutoFit/>
           </a:bodyPr>
           <a:lstStyle/>
@@ -3457,7 +3463,7 @@
           <a:noFill/>
         </p:spPr>
         <p:txBody>
-          <a:bodyPr wrap="square" lIns="0" rIns="0" tIns="0" bIns="0">
+          <a:bodyPr wrap="square" lIns="0" tIns="0" rIns="0" bIns="0">
             <a:spAutoFit/>
           </a:bodyPr>
           <a:lstStyle/>
@@ -3483,7 +3489,7 @@
 </file>
 
 <file path=ppt/slides/slide10.xml><?xml version="1.0" encoding="utf-8"?>
-<p:sld xmlns:a="http://schemas.openxmlformats.org/drawingml/2006/main" xmlns:p="http://schemas.openxmlformats.org/presentationml/2006/main" xmlns:r="http://schemas.openxmlformats.org/officeDocument/2006/relationships">
+<p:sld xmlns:a="http://schemas.openxmlformats.org/drawingml/2006/main" xmlns:r="http://schemas.openxmlformats.org/officeDocument/2006/relationships" xmlns:p="http://schemas.openxmlformats.org/presentationml/2006/main">
   <p:cSld>
     <p:spTree>
       <p:nvGrpSpPr>
@@ -3491,7 +3497,14 @@
         <p:cNvGrpSpPr/>
         <p:nvPr/>
       </p:nvGrpSpPr>
-      <p:grpSpPr/>
+      <p:grpSpPr>
+        <a:xfrm>
+          <a:off x="0" y="0"/>
+          <a:ext cx="0" cy="0"/>
+          <a:chOff x="0" y="0"/>
+          <a:chExt cx="0" cy="0"/>
+        </a:xfrm>
+      </p:grpSpPr>
       <p:sp>
         <p:nvSpPr>
           <p:cNvPr id="2" name="Rectangle 1"/>
@@ -3532,6 +3545,7 @@
           <a:lstStyle/>
           <a:p>
             <a:pPr algn="ctr"/>
+            <a:endParaRPr/>
           </a:p>
         </p:txBody>
       </p:sp>
@@ -3575,6 +3589,7 @@
           <a:lstStyle/>
           <a:p>
             <a:pPr algn="ctr"/>
+            <a:endParaRPr/>
           </a:p>
         </p:txBody>
       </p:sp>
@@ -3618,6 +3633,7 @@
           <a:lstStyle/>
           <a:p>
             <a:pPr algn="ctr"/>
+            <a:endParaRPr/>
           </a:p>
         </p:txBody>
       </p:sp>
@@ -3638,7 +3654,7 @@
           <a:noFill/>
         </p:spPr>
         <p:txBody>
-          <a:bodyPr wrap="square" lIns="0" rIns="0" tIns="0" bIns="0" anchor="ctr">
+          <a:bodyPr wrap="square" lIns="0" tIns="0" rIns="0" bIns="0" anchor="ctr">
             <a:spAutoFit/>
           </a:bodyPr>
           <a:lstStyle/>
@@ -3673,7 +3689,7 @@
           <a:noFill/>
         </p:spPr>
         <p:txBody>
-          <a:bodyPr wrap="square" lIns="0" rIns="0" tIns="0" bIns="0">
+          <a:bodyPr wrap="square" lIns="0" tIns="0" rIns="0" bIns="0">
             <a:spAutoFit/>
           </a:bodyPr>
           <a:lstStyle/>
@@ -3707,7 +3723,7 @@
           <a:noFill/>
         </p:spPr>
         <p:txBody>
-          <a:bodyPr wrap="square" lIns="0" rIns="0" tIns="0" bIns="0">
+          <a:bodyPr wrap="square" lIns="0" tIns="0" rIns="0" bIns="0">
             <a:spAutoFit/>
           </a:bodyPr>
           <a:lstStyle/>
@@ -3741,7 +3757,7 @@
           <a:noFill/>
         </p:spPr>
         <p:txBody>
-          <a:bodyPr wrap="square" lIns="0" rIns="0" tIns="0" bIns="0">
+          <a:bodyPr wrap="square" lIns="0" tIns="0" rIns="0" bIns="0">
             <a:spAutoFit/>
           </a:bodyPr>
           <a:lstStyle/>
@@ -3798,6 +3814,7 @@
           <a:lstStyle/>
           <a:p>
             <a:pPr algn="ctr"/>
+            <a:endParaRPr/>
           </a:p>
         </p:txBody>
       </p:sp>
@@ -3818,7 +3835,7 @@
           <a:noFill/>
         </p:spPr>
         <p:txBody>
-          <a:bodyPr wrap="square" lIns="0" rIns="0" tIns="0" bIns="0" anchor="ctr">
+          <a:bodyPr wrap="square" lIns="0" tIns="0" rIns="0" bIns="0" anchor="ctr">
             <a:spAutoFit/>
           </a:bodyPr>
           <a:lstStyle/>
@@ -3853,7 +3870,7 @@
           <a:noFill/>
         </p:spPr>
         <p:txBody>
-          <a:bodyPr wrap="square" lIns="0" rIns="0" tIns="0" bIns="0">
+          <a:bodyPr wrap="square" lIns="0" tIns="0" rIns="0" bIns="0">
             <a:spAutoFit/>
           </a:bodyPr>
           <a:lstStyle/>
@@ -3887,7 +3904,7 @@
           <a:noFill/>
         </p:spPr>
         <p:txBody>
-          <a:bodyPr wrap="square" lIns="0" rIns="0" tIns="0" bIns="0">
+          <a:bodyPr wrap="square" lIns="0" tIns="0" rIns="0" bIns="0">
             <a:spAutoFit/>
           </a:bodyPr>
           <a:lstStyle/>
@@ -3944,6 +3961,7 @@
           <a:lstStyle/>
           <a:p>
             <a:pPr algn="ctr"/>
+            <a:endParaRPr/>
           </a:p>
         </p:txBody>
       </p:sp>
@@ -3964,7 +3982,7 @@
           <a:noFill/>
         </p:spPr>
         <p:txBody>
-          <a:bodyPr wrap="square" lIns="0" rIns="0" tIns="0" bIns="0" anchor="ctr">
+          <a:bodyPr wrap="square" lIns="0" tIns="0" rIns="0" bIns="0" anchor="ctr">
             <a:spAutoFit/>
           </a:bodyPr>
           <a:lstStyle/>
@@ -3999,7 +4017,7 @@
           <a:noFill/>
         </p:spPr>
         <p:txBody>
-          <a:bodyPr wrap="square" lIns="0" rIns="0" tIns="0" bIns="0">
+          <a:bodyPr wrap="square" lIns="0" tIns="0" rIns="0" bIns="0">
             <a:spAutoFit/>
           </a:bodyPr>
           <a:lstStyle/>
@@ -4033,7 +4051,7 @@
           <a:noFill/>
         </p:spPr>
         <p:txBody>
-          <a:bodyPr wrap="square" lIns="0" rIns="0" tIns="0" bIns="0">
+          <a:bodyPr wrap="square" lIns="0" tIns="0" rIns="0" bIns="0">
             <a:spAutoFit/>
           </a:bodyPr>
           <a:lstStyle/>
@@ -4090,6 +4108,7 @@
           <a:lstStyle/>
           <a:p>
             <a:pPr algn="ctr"/>
+            <a:endParaRPr/>
           </a:p>
         </p:txBody>
       </p:sp>
@@ -4110,7 +4129,7 @@
           <a:noFill/>
         </p:spPr>
         <p:txBody>
-          <a:bodyPr wrap="square" lIns="0" rIns="0" tIns="0" bIns="0" anchor="ctr">
+          <a:bodyPr wrap="square" lIns="0" tIns="0" rIns="0" bIns="0" anchor="ctr">
             <a:spAutoFit/>
           </a:bodyPr>
           <a:lstStyle/>
@@ -4145,7 +4164,7 @@
           <a:noFill/>
         </p:spPr>
         <p:txBody>
-          <a:bodyPr wrap="square" lIns="0" rIns="0" tIns="0" bIns="0">
+          <a:bodyPr wrap="square" lIns="0" tIns="0" rIns="0" bIns="0">
             <a:spAutoFit/>
           </a:bodyPr>
           <a:lstStyle/>
@@ -4179,7 +4198,7 @@
           <a:noFill/>
         </p:spPr>
         <p:txBody>
-          <a:bodyPr wrap="square" lIns="0" rIns="0" tIns="0" bIns="0">
+          <a:bodyPr wrap="square" lIns="0" tIns="0" rIns="0" bIns="0">
             <a:spAutoFit/>
           </a:bodyPr>
           <a:lstStyle/>
@@ -4191,7 +4210,7 @@
                 </a:solidFill>
                 <a:latin typeface="Calibri"/>
               </a:rPr>
-              <a:t>Unblock production pipeline (currently throttled on F4 trial)</a:t>
+              <a:t>Unblock production pipeline (F4 trial throttle, especially on IoT page)</a:t>
             </a:r>
           </a:p>
         </p:txBody>
@@ -4236,6 +4255,7 @@
           <a:lstStyle/>
           <a:p>
             <a:pPr algn="ctr"/>
+            <a:endParaRPr/>
           </a:p>
         </p:txBody>
       </p:sp>
@@ -4256,7 +4276,7 @@
           <a:noFill/>
         </p:spPr>
         <p:txBody>
-          <a:bodyPr wrap="square" lIns="0" rIns="0" tIns="0" bIns="0" anchor="ctr">
+          <a:bodyPr wrap="square" lIns="0" tIns="0" rIns="0" bIns="0" anchor="ctr">
             <a:spAutoFit/>
           </a:bodyPr>
           <a:lstStyle/>
@@ -4291,7 +4311,7 @@
           <a:noFill/>
         </p:spPr>
         <p:txBody>
-          <a:bodyPr wrap="square" lIns="0" rIns="0" tIns="0" bIns="0">
+          <a:bodyPr wrap="square" lIns="0" tIns="0" rIns="0" bIns="0">
             <a:spAutoFit/>
           </a:bodyPr>
           <a:lstStyle/>
@@ -4325,7 +4345,7 @@
           <a:noFill/>
         </p:spPr>
         <p:txBody>
-          <a:bodyPr wrap="square" lIns="0" rIns="0" tIns="0" bIns="0">
+          <a:bodyPr wrap="square" lIns="0" tIns="0" rIns="0" bIns="0">
             <a:spAutoFit/>
           </a:bodyPr>
           <a:lstStyle/>
@@ -4337,7 +4357,7 @@
                 </a:solidFill>
                 <a:latin typeface="Calibri"/>
               </a:rPr>
-              <a:t>Co-selling in DACH energy vertical</a:t>
+              <a:t>Co-selling + Azure OpenAI credits to flip live Copilot from Mock to production GPT-4o</a:t>
             </a:r>
           </a:p>
         </p:txBody>
@@ -4359,7 +4379,7 @@
           <a:noFill/>
         </p:spPr>
         <p:txBody>
-          <a:bodyPr wrap="square" lIns="0" rIns="0" tIns="0" bIns="0">
+          <a:bodyPr wrap="square" lIns="0" tIns="0" rIns="0" bIns="0">
             <a:spAutoFit/>
           </a:bodyPr>
           <a:lstStyle/>
@@ -4393,7 +4413,7 @@
           <a:noFill/>
         </p:spPr>
         <p:txBody>
-          <a:bodyPr wrap="square" lIns="0" rIns="0" tIns="0" bIns="0">
+          <a:bodyPr wrap="square" lIns="0" tIns="0" rIns="0" bIns="0">
             <a:spAutoFit/>
           </a:bodyPr>
           <a:lstStyle/>
@@ -4427,7 +4447,7 @@
           <a:noFill/>
         </p:spPr>
         <p:txBody>
-          <a:bodyPr wrap="square" lIns="0" rIns="0" tIns="0" bIns="0">
+          <a:bodyPr wrap="square" lIns="0" tIns="0" rIns="0" bIns="0">
             <a:spAutoFit/>
           </a:bodyPr>
           <a:lstStyle/>
@@ -4461,7 +4481,7 @@
           <a:noFill/>
         </p:spPr>
         <p:txBody>
-          <a:bodyPr wrap="square" lIns="0" rIns="0" tIns="0" bIns="0">
+          <a:bodyPr wrap="square" lIns="0" tIns="0" rIns="0" bIns="0">
             <a:spAutoFit/>
           </a:bodyPr>
           <a:lstStyle/>
@@ -4495,7 +4515,7 @@
           <a:noFill/>
         </p:spPr>
         <p:txBody>
-          <a:bodyPr wrap="square" lIns="0" rIns="0" tIns="0" bIns="0">
+          <a:bodyPr wrap="square" lIns="0" tIns="0" rIns="0" bIns="0">
             <a:spAutoFit/>
           </a:bodyPr>
           <a:lstStyle/>
@@ -4529,7 +4549,7 @@
           <a:noFill/>
         </p:spPr>
         <p:txBody>
-          <a:bodyPr wrap="square" lIns="0" rIns="0" tIns="0" bIns="0">
+          <a:bodyPr wrap="square" lIns="0" tIns="0" rIns="0" bIns="0">
             <a:spAutoFit/>
           </a:bodyPr>
           <a:lstStyle/>
@@ -4563,7 +4583,7 @@
           <a:noFill/>
         </p:spPr>
         <p:txBody>
-          <a:bodyPr wrap="square" lIns="0" rIns="0" tIns="0" bIns="0">
+          <a:bodyPr wrap="square" lIns="0" tIns="0" rIns="0" bIns="0">
             <a:spAutoFit/>
           </a:bodyPr>
           <a:lstStyle/>
@@ -4597,7 +4617,7 @@
           <a:noFill/>
         </p:spPr>
         <p:txBody>
-          <a:bodyPr wrap="square" lIns="0" rIns="0" tIns="0" bIns="0">
+          <a:bodyPr wrap="square" lIns="0" tIns="0" rIns="0" bIns="0">
             <a:spAutoFit/>
           </a:bodyPr>
           <a:lstStyle/>
@@ -4631,7 +4651,7 @@
           <a:noFill/>
         </p:spPr>
         <p:txBody>
-          <a:bodyPr wrap="square" lIns="0" rIns="0" tIns="0" bIns="0">
+          <a:bodyPr wrap="square" lIns="0" tIns="0" rIns="0" bIns="0">
             <a:spAutoFit/>
           </a:bodyPr>
           <a:lstStyle/>
@@ -4688,6 +4708,7 @@
           <a:lstStyle/>
           <a:p>
             <a:pPr algn="ctr"/>
+            <a:endParaRPr/>
           </a:p>
         </p:txBody>
       </p:sp>
@@ -4708,7 +4729,7 @@
           <a:noFill/>
         </p:spPr>
         <p:txBody>
-          <a:bodyPr wrap="square" lIns="0" rIns="0" tIns="0" bIns="0">
+          <a:bodyPr wrap="square" lIns="0" tIns="0" rIns="0" bIns="0">
             <a:spAutoFit/>
           </a:bodyPr>
           <a:lstStyle/>
@@ -4742,7 +4763,7 @@
           <a:noFill/>
         </p:spPr>
         <p:txBody>
-          <a:bodyPr wrap="square" lIns="0" rIns="0" tIns="0" bIns="0">
+          <a:bodyPr wrap="square" lIns="0" tIns="0" rIns="0" bIns="0">
             <a:spAutoFit/>
           </a:bodyPr>
           <a:lstStyle/>
@@ -4776,7 +4797,7 @@
           <a:noFill/>
         </p:spPr>
         <p:txBody>
-          <a:bodyPr wrap="square" lIns="0" rIns="0" tIns="0" bIns="0">
+          <a:bodyPr wrap="square" lIns="0" tIns="0" rIns="0" bIns="0">
             <a:spAutoFit/>
           </a:bodyPr>
           <a:lstStyle/>
@@ -4803,7 +4824,7 @@
 </file>
 
 <file path=ppt/slides/slide2.xml><?xml version="1.0" encoding="utf-8"?>
-<p:sld xmlns:a="http://schemas.openxmlformats.org/drawingml/2006/main" xmlns:p="http://schemas.openxmlformats.org/presentationml/2006/main" xmlns:r="http://schemas.openxmlformats.org/officeDocument/2006/relationships">
+<p:sld xmlns:a="http://schemas.openxmlformats.org/drawingml/2006/main" xmlns:r="http://schemas.openxmlformats.org/officeDocument/2006/relationships" xmlns:p="http://schemas.openxmlformats.org/presentationml/2006/main">
   <p:cSld>
     <p:spTree>
       <p:nvGrpSpPr>
@@ -4811,7 +4832,14 @@
         <p:cNvGrpSpPr/>
         <p:nvPr/>
       </p:nvGrpSpPr>
-      <p:grpSpPr/>
+      <p:grpSpPr>
+        <a:xfrm>
+          <a:off x="0" y="0"/>
+          <a:ext cx="0" cy="0"/>
+          <a:chOff x="0" y="0"/>
+          <a:chExt cx="0" cy="0"/>
+        </a:xfrm>
+      </p:grpSpPr>
       <p:sp>
         <p:nvSpPr>
           <p:cNvPr id="2" name="Rectangle 1"/>
@@ -4852,6 +4880,7 @@
           <a:lstStyle/>
           <a:p>
             <a:pPr algn="ctr"/>
+            <a:endParaRPr/>
           </a:p>
         </p:txBody>
       </p:sp>
@@ -4895,6 +4924,7 @@
           <a:lstStyle/>
           <a:p>
             <a:pPr algn="ctr"/>
+            <a:endParaRPr/>
           </a:p>
         </p:txBody>
       </p:sp>
@@ -4915,7 +4945,7 @@
           <a:noFill/>
         </p:spPr>
         <p:txBody>
-          <a:bodyPr wrap="square" lIns="0" rIns="0" tIns="0" bIns="0">
+          <a:bodyPr wrap="square" lIns="0" tIns="0" rIns="0" bIns="0">
             <a:spAutoFit/>
           </a:bodyPr>
           <a:lstStyle/>
@@ -4949,7 +4979,7 @@
           <a:noFill/>
         </p:spPr>
         <p:txBody>
-          <a:bodyPr wrap="square" lIns="0" rIns="0" tIns="0" bIns="0">
+          <a:bodyPr wrap="square" lIns="0" tIns="0" rIns="0" bIns="0">
             <a:spAutoFit/>
           </a:bodyPr>
           <a:lstStyle/>
@@ -5008,6 +5038,7 @@
           <a:lstStyle/>
           <a:p>
             <a:pPr algn="ctr"/>
+            <a:endParaRPr/>
           </a:p>
         </p:txBody>
       </p:sp>
@@ -5051,6 +5082,7 @@
           <a:lstStyle/>
           <a:p>
             <a:pPr algn="ctr"/>
+            <a:endParaRPr/>
           </a:p>
         </p:txBody>
       </p:sp>
@@ -5071,7 +5103,7 @@
           <a:noFill/>
         </p:spPr>
         <p:txBody>
-          <a:bodyPr wrap="square" lIns="0" rIns="0" tIns="0" bIns="0">
+          <a:bodyPr wrap="square" lIns="0" tIns="0" rIns="0" bIns="0">
             <a:spAutoFit/>
           </a:bodyPr>
           <a:lstStyle/>
@@ -5106,7 +5138,7 @@
           <a:noFill/>
         </p:spPr>
         <p:txBody>
-          <a:bodyPr wrap="square" lIns="0" rIns="0" tIns="0" bIns="0">
+          <a:bodyPr wrap="square" lIns="0" tIns="0" rIns="0" bIns="0">
             <a:spAutoFit/>
           </a:bodyPr>
           <a:lstStyle/>
@@ -5178,6 +5210,7 @@
           <a:lstStyle/>
           <a:p>
             <a:pPr algn="ctr"/>
+            <a:endParaRPr/>
           </a:p>
         </p:txBody>
       </p:sp>
@@ -5221,6 +5254,7 @@
           <a:lstStyle/>
           <a:p>
             <a:pPr algn="ctr"/>
+            <a:endParaRPr/>
           </a:p>
         </p:txBody>
       </p:sp>
@@ -5241,7 +5275,7 @@
           <a:noFill/>
         </p:spPr>
         <p:txBody>
-          <a:bodyPr wrap="square" lIns="0" rIns="0" tIns="0" bIns="0">
+          <a:bodyPr wrap="square" lIns="0" tIns="0" rIns="0" bIns="0">
             <a:spAutoFit/>
           </a:bodyPr>
           <a:lstStyle/>
@@ -5276,7 +5310,7 @@
           <a:noFill/>
         </p:spPr>
         <p:txBody>
-          <a:bodyPr wrap="square" lIns="0" rIns="0" tIns="0" bIns="0">
+          <a:bodyPr wrap="square" lIns="0" tIns="0" rIns="0" bIns="0">
             <a:spAutoFit/>
           </a:bodyPr>
           <a:lstStyle/>
@@ -5348,6 +5382,7 @@
           <a:lstStyle/>
           <a:p>
             <a:pPr algn="ctr"/>
+            <a:endParaRPr/>
           </a:p>
         </p:txBody>
       </p:sp>
@@ -5391,6 +5426,7 @@
           <a:lstStyle/>
           <a:p>
             <a:pPr algn="ctr"/>
+            <a:endParaRPr/>
           </a:p>
         </p:txBody>
       </p:sp>
@@ -5411,7 +5447,7 @@
           <a:noFill/>
         </p:spPr>
         <p:txBody>
-          <a:bodyPr wrap="square" lIns="0" rIns="0" tIns="0" bIns="0">
+          <a:bodyPr wrap="square" lIns="0" tIns="0" rIns="0" bIns="0">
             <a:spAutoFit/>
           </a:bodyPr>
           <a:lstStyle/>
@@ -5446,7 +5482,7 @@
           <a:noFill/>
         </p:spPr>
         <p:txBody>
-          <a:bodyPr wrap="square" lIns="0" rIns="0" tIns="0" bIns="0">
+          <a:bodyPr wrap="square" lIns="0" tIns="0" rIns="0" bIns="0">
             <a:spAutoFit/>
           </a:bodyPr>
           <a:lstStyle/>
@@ -5518,6 +5554,7 @@
           <a:lstStyle/>
           <a:p>
             <a:pPr algn="ctr"/>
+            <a:endParaRPr/>
           </a:p>
         </p:txBody>
       </p:sp>
@@ -5561,6 +5598,7 @@
           <a:lstStyle/>
           <a:p>
             <a:pPr algn="ctr"/>
+            <a:endParaRPr/>
           </a:p>
         </p:txBody>
       </p:sp>
@@ -5581,7 +5619,7 @@
           <a:noFill/>
         </p:spPr>
         <p:txBody>
-          <a:bodyPr wrap="square" lIns="0" rIns="0" tIns="0" bIns="0">
+          <a:bodyPr wrap="square" lIns="0" tIns="0" rIns="0" bIns="0">
             <a:spAutoFit/>
           </a:bodyPr>
           <a:lstStyle/>
@@ -5616,7 +5654,7 @@
           <a:noFill/>
         </p:spPr>
         <p:txBody>
-          <a:bodyPr wrap="square" lIns="0" rIns="0" tIns="0" bIns="0">
+          <a:bodyPr wrap="square" lIns="0" tIns="0" rIns="0" bIns="0">
             <a:spAutoFit/>
           </a:bodyPr>
           <a:lstStyle/>
@@ -5688,6 +5726,7 @@
           <a:lstStyle/>
           <a:p>
             <a:pPr algn="ctr"/>
+            <a:endParaRPr/>
           </a:p>
         </p:txBody>
       </p:sp>
@@ -5708,7 +5747,7 @@
           <a:noFill/>
         </p:spPr>
         <p:txBody>
-          <a:bodyPr wrap="square" lIns="0" rIns="0" tIns="0" bIns="0">
+          <a:bodyPr wrap="square" lIns="0" tIns="0" rIns="0" bIns="0">
             <a:spAutoFit/>
           </a:bodyPr>
           <a:lstStyle/>
@@ -5765,6 +5804,7 @@
           <a:lstStyle/>
           <a:p>
             <a:pPr algn="ctr"/>
+            <a:endParaRPr/>
           </a:p>
         </p:txBody>
       </p:sp>
@@ -5785,7 +5825,7 @@
           <a:noFill/>
         </p:spPr>
         <p:txBody>
-          <a:bodyPr wrap="square" lIns="0" rIns="0" tIns="0" bIns="0">
+          <a:bodyPr wrap="square" lIns="0" tIns="0" rIns="0" bIns="0">
             <a:spAutoFit/>
           </a:bodyPr>
           <a:lstStyle/>
@@ -5819,7 +5859,7 @@
           <a:noFill/>
         </p:spPr>
         <p:txBody>
-          <a:bodyPr wrap="square" lIns="0" rIns="0" tIns="0" bIns="0">
+          <a:bodyPr wrap="square" lIns="0" tIns="0" rIns="0" bIns="0">
             <a:spAutoFit/>
           </a:bodyPr>
           <a:lstStyle/>
@@ -5876,6 +5916,7 @@
           <a:lstStyle/>
           <a:p>
             <a:pPr algn="ctr"/>
+            <a:endParaRPr/>
           </a:p>
         </p:txBody>
       </p:sp>
@@ -5896,7 +5937,7 @@
           <a:noFill/>
         </p:spPr>
         <p:txBody>
-          <a:bodyPr wrap="square" lIns="0" rIns="0" tIns="0" bIns="0">
+          <a:bodyPr wrap="square" lIns="0" tIns="0" rIns="0" bIns="0">
             <a:spAutoFit/>
           </a:bodyPr>
           <a:lstStyle/>
@@ -5930,7 +5971,7 @@
           <a:noFill/>
         </p:spPr>
         <p:txBody>
-          <a:bodyPr wrap="square" lIns="0" rIns="0" tIns="0" bIns="0">
+          <a:bodyPr wrap="square" lIns="0" tIns="0" rIns="0" bIns="0">
             <a:spAutoFit/>
           </a:bodyPr>
           <a:lstStyle/>
@@ -5987,6 +6028,7 @@
           <a:lstStyle/>
           <a:p>
             <a:pPr algn="ctr"/>
+            <a:endParaRPr/>
           </a:p>
         </p:txBody>
       </p:sp>
@@ -6007,7 +6049,7 @@
           <a:noFill/>
         </p:spPr>
         <p:txBody>
-          <a:bodyPr wrap="square" lIns="0" rIns="0" tIns="0" bIns="0">
+          <a:bodyPr wrap="square" lIns="0" tIns="0" rIns="0" bIns="0">
             <a:spAutoFit/>
           </a:bodyPr>
           <a:lstStyle/>
@@ -6041,7 +6083,7 @@
           <a:noFill/>
         </p:spPr>
         <p:txBody>
-          <a:bodyPr wrap="square" lIns="0" rIns="0" tIns="0" bIns="0">
+          <a:bodyPr wrap="square" lIns="0" tIns="0" rIns="0" bIns="0">
             <a:spAutoFit/>
           </a:bodyPr>
           <a:lstStyle/>
@@ -6098,6 +6140,7 @@
           <a:lstStyle/>
           <a:p>
             <a:pPr algn="ctr"/>
+            <a:endParaRPr/>
           </a:p>
         </p:txBody>
       </p:sp>
@@ -6118,7 +6161,7 @@
           <a:noFill/>
         </p:spPr>
         <p:txBody>
-          <a:bodyPr wrap="square" lIns="0" rIns="0" tIns="0" bIns="0">
+          <a:bodyPr wrap="square" lIns="0" tIns="0" rIns="0" bIns="0">
             <a:spAutoFit/>
           </a:bodyPr>
           <a:lstStyle/>
@@ -6152,7 +6195,7 @@
           <a:noFill/>
         </p:spPr>
         <p:txBody>
-          <a:bodyPr wrap="square" lIns="0" rIns="0" tIns="0" bIns="0">
+          <a:bodyPr wrap="square" lIns="0" tIns="0" rIns="0" bIns="0">
             <a:spAutoFit/>
           </a:bodyPr>
           <a:lstStyle/>
@@ -6186,7 +6229,7 @@
           <a:noFill/>
         </p:spPr>
         <p:txBody>
-          <a:bodyPr wrap="square" lIns="0" rIns="0" tIns="0" bIns="0">
+          <a:bodyPr wrap="square" lIns="0" tIns="0" rIns="0" bIns="0">
             <a:spAutoFit/>
           </a:bodyPr>
           <a:lstStyle/>
@@ -6220,7 +6263,7 @@
           <a:noFill/>
         </p:spPr>
         <p:txBody>
-          <a:bodyPr wrap="square" lIns="0" rIns="0" tIns="0" bIns="0">
+          <a:bodyPr wrap="square" lIns="0" tIns="0" rIns="0" bIns="0">
             <a:spAutoFit/>
           </a:bodyPr>
           <a:lstStyle/>
@@ -6247,7 +6290,7 @@
 </file>
 
 <file path=ppt/slides/slide3.xml><?xml version="1.0" encoding="utf-8"?>
-<p:sld xmlns:a="http://schemas.openxmlformats.org/drawingml/2006/main" xmlns:p="http://schemas.openxmlformats.org/presentationml/2006/main" xmlns:r="http://schemas.openxmlformats.org/officeDocument/2006/relationships">
+<p:sld xmlns:a="http://schemas.openxmlformats.org/drawingml/2006/main" xmlns:r="http://schemas.openxmlformats.org/officeDocument/2006/relationships" xmlns:p="http://schemas.openxmlformats.org/presentationml/2006/main">
   <p:cSld>
     <p:spTree>
       <p:nvGrpSpPr>
@@ -6255,7 +6298,14 @@
         <p:cNvGrpSpPr/>
         <p:nvPr/>
       </p:nvGrpSpPr>
-      <p:grpSpPr/>
+      <p:grpSpPr>
+        <a:xfrm>
+          <a:off x="0" y="0"/>
+          <a:ext cx="0" cy="0"/>
+          <a:chOff x="0" y="0"/>
+          <a:chExt cx="0" cy="0"/>
+        </a:xfrm>
+      </p:grpSpPr>
       <p:sp>
         <p:nvSpPr>
           <p:cNvPr id="2" name="Rectangle 1"/>
@@ -6296,6 +6346,7 @@
           <a:lstStyle/>
           <a:p>
             <a:pPr algn="ctr"/>
+            <a:endParaRPr/>
           </a:p>
         </p:txBody>
       </p:sp>
@@ -6339,6 +6390,7 @@
           <a:lstStyle/>
           <a:p>
             <a:pPr algn="ctr"/>
+            <a:endParaRPr/>
           </a:p>
         </p:txBody>
       </p:sp>
@@ -6359,7 +6411,7 @@
           <a:noFill/>
         </p:spPr>
         <p:txBody>
-          <a:bodyPr wrap="square" lIns="0" rIns="0" tIns="0" bIns="0">
+          <a:bodyPr wrap="square" lIns="0" tIns="0" rIns="0" bIns="0">
             <a:spAutoFit/>
           </a:bodyPr>
           <a:lstStyle/>
@@ -6393,7 +6445,7 @@
           <a:noFill/>
         </p:spPr>
         <p:txBody>
-          <a:bodyPr wrap="square" lIns="0" rIns="0" tIns="0" bIns="0">
+          <a:bodyPr wrap="square" lIns="0" tIns="0" rIns="0" bIns="0">
             <a:spAutoFit/>
           </a:bodyPr>
           <a:lstStyle/>
@@ -6452,6 +6504,7 @@
           <a:lstStyle/>
           <a:p>
             <a:pPr algn="ctr"/>
+            <a:endParaRPr/>
           </a:p>
         </p:txBody>
       </p:sp>
@@ -6495,6 +6548,7 @@
           <a:lstStyle/>
           <a:p>
             <a:pPr algn="ctr"/>
+            <a:endParaRPr/>
           </a:p>
         </p:txBody>
       </p:sp>
@@ -6538,6 +6592,7 @@
           <a:lstStyle/>
           <a:p>
             <a:pPr algn="ctr"/>
+            <a:endParaRPr/>
           </a:p>
         </p:txBody>
       </p:sp>
@@ -6558,7 +6613,7 @@
           <a:noFill/>
         </p:spPr>
         <p:txBody>
-          <a:bodyPr wrap="square" lIns="0" rIns="0" tIns="0" bIns="0" anchor="ctr">
+          <a:bodyPr wrap="square" lIns="0" tIns="0" rIns="0" bIns="0" anchor="ctr">
             <a:spAutoFit/>
           </a:bodyPr>
           <a:lstStyle/>
@@ -6593,7 +6648,7 @@
           <a:noFill/>
         </p:spPr>
         <p:txBody>
-          <a:bodyPr wrap="square" lIns="0" rIns="0" tIns="0" bIns="0">
+          <a:bodyPr wrap="square" lIns="0" tIns="0" rIns="0" bIns="0">
             <a:spAutoFit/>
           </a:bodyPr>
           <a:lstStyle/>
@@ -6627,7 +6682,7 @@
           <a:noFill/>
         </p:spPr>
         <p:txBody>
-          <a:bodyPr wrap="square" lIns="0" rIns="0" tIns="0" bIns="0">
+          <a:bodyPr wrap="square" lIns="0" tIns="0" rIns="0" bIns="0">
             <a:spAutoFit/>
           </a:bodyPr>
           <a:lstStyle/>
@@ -6686,6 +6741,7 @@
           <a:lstStyle/>
           <a:p>
             <a:pPr algn="ctr"/>
+            <a:endParaRPr/>
           </a:p>
         </p:txBody>
       </p:sp>
@@ -6729,6 +6785,7 @@
           <a:lstStyle/>
           <a:p>
             <a:pPr algn="ctr"/>
+            <a:endParaRPr/>
           </a:p>
         </p:txBody>
       </p:sp>
@@ -6772,6 +6829,7 @@
           <a:lstStyle/>
           <a:p>
             <a:pPr algn="ctr"/>
+            <a:endParaRPr/>
           </a:p>
         </p:txBody>
       </p:sp>
@@ -6792,7 +6850,7 @@
           <a:noFill/>
         </p:spPr>
         <p:txBody>
-          <a:bodyPr wrap="square" lIns="0" rIns="0" tIns="0" bIns="0" anchor="ctr">
+          <a:bodyPr wrap="square" lIns="0" tIns="0" rIns="0" bIns="0" anchor="ctr">
             <a:spAutoFit/>
           </a:bodyPr>
           <a:lstStyle/>
@@ -6827,7 +6885,7 @@
           <a:noFill/>
         </p:spPr>
         <p:txBody>
-          <a:bodyPr wrap="square" lIns="0" rIns="0" tIns="0" bIns="0">
+          <a:bodyPr wrap="square" lIns="0" tIns="0" rIns="0" bIns="0">
             <a:spAutoFit/>
           </a:bodyPr>
           <a:lstStyle/>
@@ -6861,7 +6919,7 @@
           <a:noFill/>
         </p:spPr>
         <p:txBody>
-          <a:bodyPr wrap="square" lIns="0" rIns="0" tIns="0" bIns="0">
+          <a:bodyPr wrap="square" lIns="0" tIns="0" rIns="0" bIns="0">
             <a:spAutoFit/>
           </a:bodyPr>
           <a:lstStyle/>
@@ -6920,6 +6978,7 @@
           <a:lstStyle/>
           <a:p>
             <a:pPr algn="ctr"/>
+            <a:endParaRPr/>
           </a:p>
         </p:txBody>
       </p:sp>
@@ -6963,6 +7022,7 @@
           <a:lstStyle/>
           <a:p>
             <a:pPr algn="ctr"/>
+            <a:endParaRPr/>
           </a:p>
         </p:txBody>
       </p:sp>
@@ -7006,6 +7066,7 @@
           <a:lstStyle/>
           <a:p>
             <a:pPr algn="ctr"/>
+            <a:endParaRPr/>
           </a:p>
         </p:txBody>
       </p:sp>
@@ -7026,7 +7087,7 @@
           <a:noFill/>
         </p:spPr>
         <p:txBody>
-          <a:bodyPr wrap="square" lIns="0" rIns="0" tIns="0" bIns="0" anchor="ctr">
+          <a:bodyPr wrap="square" lIns="0" tIns="0" rIns="0" bIns="0" anchor="ctr">
             <a:spAutoFit/>
           </a:bodyPr>
           <a:lstStyle/>
@@ -7061,7 +7122,7 @@
           <a:noFill/>
         </p:spPr>
         <p:txBody>
-          <a:bodyPr wrap="square" lIns="0" rIns="0" tIns="0" bIns="0">
+          <a:bodyPr wrap="square" lIns="0" tIns="0" rIns="0" bIns="0">
             <a:spAutoFit/>
           </a:bodyPr>
           <a:lstStyle/>
@@ -7095,7 +7156,7 @@
           <a:noFill/>
         </p:spPr>
         <p:txBody>
-          <a:bodyPr wrap="square" lIns="0" rIns="0" tIns="0" bIns="0">
+          <a:bodyPr wrap="square" lIns="0" tIns="0" rIns="0" bIns="0">
             <a:spAutoFit/>
           </a:bodyPr>
           <a:lstStyle/>
@@ -7154,6 +7215,7 @@
           <a:lstStyle/>
           <a:p>
             <a:pPr algn="ctr"/>
+            <a:endParaRPr/>
           </a:p>
         </p:txBody>
       </p:sp>
@@ -7197,6 +7259,7 @@
           <a:lstStyle/>
           <a:p>
             <a:pPr algn="ctr"/>
+            <a:endParaRPr/>
           </a:p>
         </p:txBody>
       </p:sp>
@@ -7240,6 +7303,7 @@
           <a:lstStyle/>
           <a:p>
             <a:pPr algn="ctr"/>
+            <a:endParaRPr/>
           </a:p>
         </p:txBody>
       </p:sp>
@@ -7260,7 +7324,7 @@
           <a:noFill/>
         </p:spPr>
         <p:txBody>
-          <a:bodyPr wrap="square" lIns="0" rIns="0" tIns="0" bIns="0" anchor="ctr">
+          <a:bodyPr wrap="square" lIns="0" tIns="0" rIns="0" bIns="0" anchor="ctr">
             <a:spAutoFit/>
           </a:bodyPr>
           <a:lstStyle/>
@@ -7295,7 +7359,7 @@
           <a:noFill/>
         </p:spPr>
         <p:txBody>
-          <a:bodyPr wrap="square" lIns="0" rIns="0" tIns="0" bIns="0">
+          <a:bodyPr wrap="square" lIns="0" tIns="0" rIns="0" bIns="0">
             <a:spAutoFit/>
           </a:bodyPr>
           <a:lstStyle/>
@@ -7329,7 +7393,7 @@
           <a:noFill/>
         </p:spPr>
         <p:txBody>
-          <a:bodyPr wrap="square" lIns="0" rIns="0" tIns="0" bIns="0">
+          <a:bodyPr wrap="square" lIns="0" tIns="0" rIns="0" bIns="0">
             <a:spAutoFit/>
           </a:bodyPr>
           <a:lstStyle/>
@@ -7388,6 +7452,7 @@
           <a:lstStyle/>
           <a:p>
             <a:pPr algn="ctr"/>
+            <a:endParaRPr/>
           </a:p>
         </p:txBody>
       </p:sp>
@@ -7431,6 +7496,7 @@
           <a:lstStyle/>
           <a:p>
             <a:pPr algn="ctr"/>
+            <a:endParaRPr/>
           </a:p>
         </p:txBody>
       </p:sp>
@@ -7474,6 +7540,7 @@
           <a:lstStyle/>
           <a:p>
             <a:pPr algn="ctr"/>
+            <a:endParaRPr/>
           </a:p>
         </p:txBody>
       </p:sp>
@@ -7494,7 +7561,7 @@
           <a:noFill/>
         </p:spPr>
         <p:txBody>
-          <a:bodyPr wrap="square" lIns="0" rIns="0" tIns="0" bIns="0" anchor="ctr">
+          <a:bodyPr wrap="square" lIns="0" tIns="0" rIns="0" bIns="0" anchor="ctr">
             <a:spAutoFit/>
           </a:bodyPr>
           <a:lstStyle/>
@@ -7529,7 +7596,7 @@
           <a:noFill/>
         </p:spPr>
         <p:txBody>
-          <a:bodyPr wrap="square" lIns="0" rIns="0" tIns="0" bIns="0">
+          <a:bodyPr wrap="square" lIns="0" tIns="0" rIns="0" bIns="0">
             <a:spAutoFit/>
           </a:bodyPr>
           <a:lstStyle/>
@@ -7563,7 +7630,7 @@
           <a:noFill/>
         </p:spPr>
         <p:txBody>
-          <a:bodyPr wrap="square" lIns="0" rIns="0" tIns="0" bIns="0">
+          <a:bodyPr wrap="square" lIns="0" tIns="0" rIns="0" bIns="0">
             <a:spAutoFit/>
           </a:bodyPr>
           <a:lstStyle/>
@@ -7622,6 +7689,7 @@
           <a:lstStyle/>
           <a:p>
             <a:pPr algn="ctr"/>
+            <a:endParaRPr/>
           </a:p>
         </p:txBody>
       </p:sp>
@@ -7665,6 +7733,7 @@
           <a:lstStyle/>
           <a:p>
             <a:pPr algn="ctr"/>
+            <a:endParaRPr/>
           </a:p>
         </p:txBody>
       </p:sp>
@@ -7708,6 +7777,7 @@
           <a:lstStyle/>
           <a:p>
             <a:pPr algn="ctr"/>
+            <a:endParaRPr/>
           </a:p>
         </p:txBody>
       </p:sp>
@@ -7728,7 +7798,7 @@
           <a:noFill/>
         </p:spPr>
         <p:txBody>
-          <a:bodyPr wrap="square" lIns="0" rIns="0" tIns="0" bIns="0" anchor="ctr">
+          <a:bodyPr wrap="square" lIns="0" tIns="0" rIns="0" bIns="0" anchor="ctr">
             <a:spAutoFit/>
           </a:bodyPr>
           <a:lstStyle/>
@@ -7763,7 +7833,7 @@
           <a:noFill/>
         </p:spPr>
         <p:txBody>
-          <a:bodyPr wrap="square" lIns="0" rIns="0" tIns="0" bIns="0">
+          <a:bodyPr wrap="square" lIns="0" tIns="0" rIns="0" bIns="0">
             <a:spAutoFit/>
           </a:bodyPr>
           <a:lstStyle/>
@@ -7797,7 +7867,7 @@
           <a:noFill/>
         </p:spPr>
         <p:txBody>
-          <a:bodyPr wrap="square" lIns="0" rIns="0" tIns="0" bIns="0">
+          <a:bodyPr wrap="square" lIns="0" tIns="0" rIns="0" bIns="0">
             <a:spAutoFit/>
           </a:bodyPr>
           <a:lstStyle/>
@@ -7831,7 +7901,7 @@
           <a:noFill/>
         </p:spPr>
         <p:txBody>
-          <a:bodyPr wrap="square" lIns="0" rIns="0" tIns="0" bIns="0">
+          <a:bodyPr wrap="square" lIns="0" tIns="0" rIns="0" bIns="0">
             <a:spAutoFit/>
           </a:bodyPr>
           <a:lstStyle/>
@@ -7865,7 +7935,7 @@
           <a:noFill/>
         </p:spPr>
         <p:txBody>
-          <a:bodyPr wrap="square" lIns="0" rIns="0" tIns="0" bIns="0">
+          <a:bodyPr wrap="square" lIns="0" tIns="0" rIns="0" bIns="0">
             <a:spAutoFit/>
           </a:bodyPr>
           <a:lstStyle/>
@@ -7892,7 +7962,7 @@
 </file>
 
 <file path=ppt/slides/slide4.xml><?xml version="1.0" encoding="utf-8"?>
-<p:sld xmlns:a="http://schemas.openxmlformats.org/drawingml/2006/main" xmlns:p="http://schemas.openxmlformats.org/presentationml/2006/main" xmlns:r="http://schemas.openxmlformats.org/officeDocument/2006/relationships">
+<p:sld xmlns:a="http://schemas.openxmlformats.org/drawingml/2006/main" xmlns:r="http://schemas.openxmlformats.org/officeDocument/2006/relationships" xmlns:p="http://schemas.openxmlformats.org/presentationml/2006/main">
   <p:cSld>
     <p:spTree>
       <p:nvGrpSpPr>
@@ -7900,7 +7970,14 @@
         <p:cNvGrpSpPr/>
         <p:nvPr/>
       </p:nvGrpSpPr>
-      <p:grpSpPr/>
+      <p:grpSpPr>
+        <a:xfrm>
+          <a:off x="0" y="0"/>
+          <a:ext cx="0" cy="0"/>
+          <a:chOff x="0" y="0"/>
+          <a:chExt cx="0" cy="0"/>
+        </a:xfrm>
+      </p:grpSpPr>
       <p:sp>
         <p:nvSpPr>
           <p:cNvPr id="2" name="Rectangle 1"/>
@@ -7941,6 +8018,7 @@
           <a:lstStyle/>
           <a:p>
             <a:pPr algn="ctr"/>
+            <a:endParaRPr/>
           </a:p>
         </p:txBody>
       </p:sp>
@@ -7984,6 +8062,7 @@
           <a:lstStyle/>
           <a:p>
             <a:pPr algn="ctr"/>
+            <a:endParaRPr/>
           </a:p>
         </p:txBody>
       </p:sp>
@@ -8004,7 +8083,7 @@
           <a:noFill/>
         </p:spPr>
         <p:txBody>
-          <a:bodyPr wrap="square" lIns="0" rIns="0" tIns="0" bIns="0">
+          <a:bodyPr wrap="square" lIns="0" tIns="0" rIns="0" bIns="0">
             <a:spAutoFit/>
           </a:bodyPr>
           <a:lstStyle/>
@@ -8038,7 +8117,7 @@
           <a:noFill/>
         </p:spPr>
         <p:txBody>
-          <a:bodyPr wrap="square" lIns="0" rIns="0" tIns="0" bIns="0">
+          <a:bodyPr wrap="square" lIns="0" tIns="0" rIns="0" bIns="0">
             <a:spAutoFit/>
           </a:bodyPr>
           <a:lstStyle/>
@@ -8097,6 +8176,7 @@
           <a:lstStyle/>
           <a:p>
             <a:pPr algn="ctr"/>
+            <a:endParaRPr/>
           </a:p>
         </p:txBody>
       </p:sp>
@@ -8117,7 +8197,7 @@
           <a:noFill/>
         </p:spPr>
         <p:txBody>
-          <a:bodyPr wrap="square" lIns="0" rIns="0" tIns="0" bIns="0">
+          <a:bodyPr wrap="square" lIns="0" tIns="0" rIns="0" bIns="0">
             <a:spAutoFit/>
           </a:bodyPr>
           <a:lstStyle/>
@@ -8174,6 +8254,7 @@
           <a:lstStyle/>
           <a:p>
             <a:pPr algn="ctr"/>
+            <a:endParaRPr/>
           </a:p>
         </p:txBody>
       </p:sp>
@@ -8194,7 +8275,7 @@
           <a:noFill/>
         </p:spPr>
         <p:txBody>
-          <a:bodyPr wrap="square" lIns="0" rIns="0" tIns="0" bIns="0">
+          <a:bodyPr wrap="square" lIns="0" tIns="0" rIns="0" bIns="0">
             <a:spAutoFit/>
           </a:bodyPr>
           <a:lstStyle/>
@@ -8228,7 +8309,7 @@
           <a:noFill/>
         </p:spPr>
         <p:txBody>
-          <a:bodyPr wrap="square" lIns="0" rIns="0" tIns="0" bIns="0">
+          <a:bodyPr wrap="square" lIns="0" tIns="0" rIns="0" bIns="0">
             <a:spAutoFit/>
           </a:bodyPr>
           <a:lstStyle/>
@@ -8285,6 +8366,7 @@
           <a:lstStyle/>
           <a:p>
             <a:pPr algn="ctr"/>
+            <a:endParaRPr/>
           </a:p>
         </p:txBody>
       </p:sp>
@@ -8305,7 +8387,7 @@
           <a:noFill/>
         </p:spPr>
         <p:txBody>
-          <a:bodyPr wrap="square" lIns="0" rIns="0" tIns="0" bIns="0">
+          <a:bodyPr wrap="square" lIns="0" tIns="0" rIns="0" bIns="0">
             <a:spAutoFit/>
           </a:bodyPr>
           <a:lstStyle/>
@@ -8339,7 +8421,7 @@
           <a:noFill/>
         </p:spPr>
         <p:txBody>
-          <a:bodyPr wrap="square" lIns="0" rIns="0" tIns="0" bIns="0">
+          <a:bodyPr wrap="square" lIns="0" tIns="0" rIns="0" bIns="0">
             <a:spAutoFit/>
           </a:bodyPr>
           <a:lstStyle/>
@@ -8396,6 +8478,7 @@
           <a:lstStyle/>
           <a:p>
             <a:pPr algn="ctr"/>
+            <a:endParaRPr/>
           </a:p>
         </p:txBody>
       </p:sp>
@@ -8416,7 +8499,7 @@
           <a:noFill/>
         </p:spPr>
         <p:txBody>
-          <a:bodyPr wrap="square" lIns="0" rIns="0" tIns="0" bIns="0">
+          <a:bodyPr wrap="square" lIns="0" tIns="0" rIns="0" bIns="0">
             <a:spAutoFit/>
           </a:bodyPr>
           <a:lstStyle/>
@@ -8450,7 +8533,7 @@
           <a:noFill/>
         </p:spPr>
         <p:txBody>
-          <a:bodyPr wrap="square" lIns="0" rIns="0" tIns="0" bIns="0">
+          <a:bodyPr wrap="square" lIns="0" tIns="0" rIns="0" bIns="0">
             <a:spAutoFit/>
           </a:bodyPr>
           <a:lstStyle/>
@@ -8484,7 +8567,7 @@
           <a:noFill/>
         </p:spPr>
         <p:txBody>
-          <a:bodyPr wrap="square" lIns="0" rIns="0" tIns="0" bIns="0">
+          <a:bodyPr wrap="square" lIns="0" tIns="0" rIns="0" bIns="0">
             <a:spAutoFit/>
           </a:bodyPr>
           <a:lstStyle/>
@@ -8543,6 +8626,7 @@
           <a:lstStyle/>
           <a:p>
             <a:pPr algn="ctr"/>
+            <a:endParaRPr/>
           </a:p>
         </p:txBody>
       </p:sp>
@@ -8563,7 +8647,7 @@
           <a:noFill/>
         </p:spPr>
         <p:txBody>
-          <a:bodyPr wrap="square" lIns="0" rIns="0" tIns="0" bIns="0">
+          <a:bodyPr wrap="square" lIns="0" tIns="0" rIns="0" bIns="0">
             <a:spAutoFit/>
           </a:bodyPr>
           <a:lstStyle/>
@@ -8620,6 +8704,7 @@
           <a:lstStyle/>
           <a:p>
             <a:pPr algn="ctr"/>
+            <a:endParaRPr/>
           </a:p>
         </p:txBody>
       </p:sp>
@@ -8640,7 +8725,7 @@
           <a:noFill/>
         </p:spPr>
         <p:txBody>
-          <a:bodyPr wrap="square" lIns="0" rIns="0" tIns="0" bIns="0" anchor="ctr">
+          <a:bodyPr wrap="square" lIns="0" tIns="0" rIns="0" bIns="0" anchor="ctr">
             <a:spAutoFit/>
           </a:bodyPr>
           <a:lstStyle/>
@@ -8675,7 +8760,7 @@
           <a:noFill/>
         </p:spPr>
         <p:txBody>
-          <a:bodyPr wrap="square" lIns="0" rIns="0" tIns="0" bIns="0">
+          <a:bodyPr wrap="square" lIns="0" tIns="0" rIns="0" bIns="0">
             <a:spAutoFit/>
           </a:bodyPr>
           <a:lstStyle/>
@@ -8709,7 +8794,7 @@
           <a:noFill/>
         </p:spPr>
         <p:txBody>
-          <a:bodyPr wrap="square" lIns="0" rIns="0" tIns="0" bIns="0">
+          <a:bodyPr wrap="square" lIns="0" tIns="0" rIns="0" bIns="0">
             <a:spAutoFit/>
           </a:bodyPr>
           <a:lstStyle/>
@@ -8766,6 +8851,7 @@
           <a:lstStyle/>
           <a:p>
             <a:pPr algn="ctr"/>
+            <a:endParaRPr/>
           </a:p>
         </p:txBody>
       </p:sp>
@@ -8786,7 +8872,7 @@
           <a:noFill/>
         </p:spPr>
         <p:txBody>
-          <a:bodyPr wrap="square" lIns="0" rIns="0" tIns="0" bIns="0" anchor="ctr">
+          <a:bodyPr wrap="square" lIns="0" tIns="0" rIns="0" bIns="0" anchor="ctr">
             <a:spAutoFit/>
           </a:bodyPr>
           <a:lstStyle/>
@@ -8821,7 +8907,7 @@
           <a:noFill/>
         </p:spPr>
         <p:txBody>
-          <a:bodyPr wrap="square" lIns="0" rIns="0" tIns="0" bIns="0">
+          <a:bodyPr wrap="square" lIns="0" tIns="0" rIns="0" bIns="0">
             <a:spAutoFit/>
           </a:bodyPr>
           <a:lstStyle/>
@@ -8855,7 +8941,7 @@
           <a:noFill/>
         </p:spPr>
         <p:txBody>
-          <a:bodyPr wrap="square" lIns="0" rIns="0" tIns="0" bIns="0">
+          <a:bodyPr wrap="square" lIns="0" tIns="0" rIns="0" bIns="0">
             <a:spAutoFit/>
           </a:bodyPr>
           <a:lstStyle/>
@@ -8912,6 +8998,7 @@
           <a:lstStyle/>
           <a:p>
             <a:pPr algn="ctr"/>
+            <a:endParaRPr/>
           </a:p>
         </p:txBody>
       </p:sp>
@@ -8932,7 +9019,7 @@
           <a:noFill/>
         </p:spPr>
         <p:txBody>
-          <a:bodyPr wrap="square" lIns="0" rIns="0" tIns="0" bIns="0" anchor="ctr">
+          <a:bodyPr wrap="square" lIns="0" tIns="0" rIns="0" bIns="0" anchor="ctr">
             <a:spAutoFit/>
           </a:bodyPr>
           <a:lstStyle/>
@@ -8967,7 +9054,7 @@
           <a:noFill/>
         </p:spPr>
         <p:txBody>
-          <a:bodyPr wrap="square" lIns="0" rIns="0" tIns="0" bIns="0">
+          <a:bodyPr wrap="square" lIns="0" tIns="0" rIns="0" bIns="0">
             <a:spAutoFit/>
           </a:bodyPr>
           <a:lstStyle/>
@@ -9001,7 +9088,7 @@
           <a:noFill/>
         </p:spPr>
         <p:txBody>
-          <a:bodyPr wrap="square" lIns="0" rIns="0" tIns="0" bIns="0">
+          <a:bodyPr wrap="square" lIns="0" tIns="0" rIns="0" bIns="0">
             <a:spAutoFit/>
           </a:bodyPr>
           <a:lstStyle/>
@@ -9058,6 +9145,7 @@
           <a:lstStyle/>
           <a:p>
             <a:pPr algn="ctr"/>
+            <a:endParaRPr/>
           </a:p>
         </p:txBody>
       </p:sp>
@@ -9078,7 +9166,7 @@
           <a:noFill/>
         </p:spPr>
         <p:txBody>
-          <a:bodyPr wrap="square" lIns="0" rIns="0" tIns="0" bIns="0" anchor="ctr">
+          <a:bodyPr wrap="square" lIns="0" tIns="0" rIns="0" bIns="0" anchor="ctr">
             <a:spAutoFit/>
           </a:bodyPr>
           <a:lstStyle/>
@@ -9113,7 +9201,7 @@
           <a:noFill/>
         </p:spPr>
         <p:txBody>
-          <a:bodyPr wrap="square" lIns="0" rIns="0" tIns="0" bIns="0">
+          <a:bodyPr wrap="square" lIns="0" tIns="0" rIns="0" bIns="0">
             <a:spAutoFit/>
           </a:bodyPr>
           <a:lstStyle/>
@@ -9147,7 +9235,7 @@
           <a:noFill/>
         </p:spPr>
         <p:txBody>
-          <a:bodyPr wrap="square" lIns="0" rIns="0" tIns="0" bIns="0">
+          <a:bodyPr wrap="square" lIns="0" tIns="0" rIns="0" bIns="0">
             <a:spAutoFit/>
           </a:bodyPr>
           <a:lstStyle/>
@@ -9204,6 +9292,7 @@
           <a:lstStyle/>
           <a:p>
             <a:pPr algn="ctr"/>
+            <a:endParaRPr/>
           </a:p>
         </p:txBody>
       </p:sp>
@@ -9224,7 +9313,7 @@
           <a:noFill/>
         </p:spPr>
         <p:txBody>
-          <a:bodyPr wrap="square" lIns="0" rIns="0" tIns="0" bIns="0" anchor="ctr">
+          <a:bodyPr wrap="square" lIns="0" tIns="0" rIns="0" bIns="0" anchor="ctr">
             <a:spAutoFit/>
           </a:bodyPr>
           <a:lstStyle/>
@@ -9259,7 +9348,7 @@
           <a:noFill/>
         </p:spPr>
         <p:txBody>
-          <a:bodyPr wrap="square" lIns="0" rIns="0" tIns="0" bIns="0">
+          <a:bodyPr wrap="square" lIns="0" tIns="0" rIns="0" bIns="0">
             <a:spAutoFit/>
           </a:bodyPr>
           <a:lstStyle/>
@@ -9293,7 +9382,7 @@
           <a:noFill/>
         </p:spPr>
         <p:txBody>
-          <a:bodyPr wrap="square" lIns="0" rIns="0" tIns="0" bIns="0">
+          <a:bodyPr wrap="square" lIns="0" tIns="0" rIns="0" bIns="0">
             <a:spAutoFit/>
           </a:bodyPr>
           <a:lstStyle/>
@@ -9327,7 +9416,7 @@
           <a:noFill/>
         </p:spPr>
         <p:txBody>
-          <a:bodyPr wrap="square" lIns="0" rIns="0" tIns="0" bIns="0">
+          <a:bodyPr wrap="square" lIns="0" tIns="0" rIns="0" bIns="0">
             <a:spAutoFit/>
           </a:bodyPr>
           <a:lstStyle/>
@@ -9361,7 +9450,7 @@
           <a:noFill/>
         </p:spPr>
         <p:txBody>
-          <a:bodyPr wrap="square" lIns="0" rIns="0" tIns="0" bIns="0">
+          <a:bodyPr wrap="square" lIns="0" tIns="0" rIns="0" bIns="0">
             <a:spAutoFit/>
           </a:bodyPr>
           <a:lstStyle/>
@@ -9388,7 +9477,7 @@
 </file>
 
 <file path=ppt/slides/slide5.xml><?xml version="1.0" encoding="utf-8"?>
-<p:sld xmlns:a="http://schemas.openxmlformats.org/drawingml/2006/main" xmlns:p="http://schemas.openxmlformats.org/presentationml/2006/main" xmlns:r="http://schemas.openxmlformats.org/officeDocument/2006/relationships">
+<p:sld xmlns:a="http://schemas.openxmlformats.org/drawingml/2006/main" xmlns:r="http://schemas.openxmlformats.org/officeDocument/2006/relationships" xmlns:p="http://schemas.openxmlformats.org/presentationml/2006/main">
   <p:cSld>
     <p:spTree>
       <p:nvGrpSpPr>
@@ -9396,7 +9485,14 @@
         <p:cNvGrpSpPr/>
         <p:nvPr/>
       </p:nvGrpSpPr>
-      <p:grpSpPr/>
+      <p:grpSpPr>
+        <a:xfrm>
+          <a:off x="0" y="0"/>
+          <a:ext cx="0" cy="0"/>
+          <a:chOff x="0" y="0"/>
+          <a:chExt cx="0" cy="0"/>
+        </a:xfrm>
+      </p:grpSpPr>
       <p:sp>
         <p:nvSpPr>
           <p:cNvPr id="2" name="Rectangle 1"/>
@@ -9437,6 +9533,7 @@
           <a:lstStyle/>
           <a:p>
             <a:pPr algn="ctr"/>
+            <a:endParaRPr/>
           </a:p>
         </p:txBody>
       </p:sp>
@@ -9480,6 +9577,7 @@
           <a:lstStyle/>
           <a:p>
             <a:pPr algn="ctr"/>
+            <a:endParaRPr/>
           </a:p>
         </p:txBody>
       </p:sp>
@@ -9500,7 +9598,7 @@
           <a:noFill/>
         </p:spPr>
         <p:txBody>
-          <a:bodyPr wrap="square" lIns="0" rIns="0" tIns="0" bIns="0">
+          <a:bodyPr wrap="square" lIns="0" tIns="0" rIns="0" bIns="0">
             <a:spAutoFit/>
           </a:bodyPr>
           <a:lstStyle/>
@@ -9534,7 +9632,7 @@
           <a:noFill/>
         </p:spPr>
         <p:txBody>
-          <a:bodyPr wrap="square" lIns="0" rIns="0" tIns="0" bIns="0">
+          <a:bodyPr wrap="square" lIns="0" tIns="0" rIns="0" bIns="0">
             <a:spAutoFit/>
           </a:bodyPr>
           <a:lstStyle/>
@@ -9593,6 +9691,7 @@
           <a:lstStyle/>
           <a:p>
             <a:pPr algn="ctr"/>
+            <a:endParaRPr/>
           </a:p>
         </p:txBody>
       </p:sp>
@@ -9613,7 +9712,7 @@
           <a:noFill/>
         </p:spPr>
         <p:txBody>
-          <a:bodyPr wrap="square" lIns="0" rIns="0" tIns="0" bIns="0" anchor="ctr">
+          <a:bodyPr wrap="square" lIns="0" tIns="0" rIns="0" bIns="0" anchor="ctr">
             <a:spAutoFit/>
           </a:bodyPr>
           <a:lstStyle/>
@@ -9647,7 +9746,7 @@
           <a:noFill/>
         </p:spPr>
         <p:txBody>
-          <a:bodyPr wrap="square" lIns="0" rIns="0" tIns="0" bIns="0" anchor="ctr">
+          <a:bodyPr wrap="square" lIns="0" tIns="0" rIns="0" bIns="0" anchor="ctr">
             <a:spAutoFit/>
           </a:bodyPr>
           <a:lstStyle/>
@@ -9659,7 +9758,7 @@
                 </a:solidFill>
                 <a:latin typeface="Calibri"/>
               </a:rPr>
-              <a:t>Power BI Reports (9 pages)  ·  Next.js Web App  ·  Microsoft Teams alerts</a:t>
+              <a:t>Power BI Reports (9 pages)  ·  Next.js Web App (live)  ·  AI Copilot (live, LLM tool use)</a:t>
             </a:r>
           </a:p>
         </p:txBody>
@@ -9706,6 +9805,7 @@
           <a:lstStyle/>
           <a:p>
             <a:pPr algn="ctr"/>
+            <a:endParaRPr/>
           </a:p>
         </p:txBody>
       </p:sp>
@@ -9726,7 +9826,7 @@
           <a:noFill/>
         </p:spPr>
         <p:txBody>
-          <a:bodyPr wrap="square" lIns="0" rIns="0" tIns="0" bIns="0" anchor="ctr">
+          <a:bodyPr wrap="square" lIns="0" tIns="0" rIns="0" bIns="0" anchor="ctr">
             <a:spAutoFit/>
           </a:bodyPr>
           <a:lstStyle/>
@@ -9760,7 +9860,7 @@
           <a:noFill/>
         </p:spPr>
         <p:txBody>
-          <a:bodyPr wrap="square" lIns="0" rIns="0" tIns="0" bIns="0" anchor="ctr">
+          <a:bodyPr wrap="square" lIns="0" tIns="0" rIns="0" bIns="0" anchor="ctr">
             <a:spAutoFit/>
           </a:bodyPr>
           <a:lstStyle/>
@@ -9819,6 +9919,7 @@
           <a:lstStyle/>
           <a:p>
             <a:pPr algn="ctr"/>
+            <a:endParaRPr/>
           </a:p>
         </p:txBody>
       </p:sp>
@@ -9839,7 +9940,7 @@
           <a:noFill/>
         </p:spPr>
         <p:txBody>
-          <a:bodyPr wrap="square" lIns="0" rIns="0" tIns="0" bIns="0" anchor="ctr">
+          <a:bodyPr wrap="square" lIns="0" tIns="0" rIns="0" bIns="0" anchor="ctr">
             <a:spAutoFit/>
           </a:bodyPr>
           <a:lstStyle/>
@@ -9873,7 +9974,7 @@
           <a:noFill/>
         </p:spPr>
         <p:txBody>
-          <a:bodyPr wrap="square" lIns="0" rIns="0" tIns="0" bIns="0" anchor="ctr">
+          <a:bodyPr wrap="square" lIns="0" tIns="0" rIns="0" bIns="0" anchor="ctr">
             <a:spAutoFit/>
           </a:bodyPr>
           <a:lstStyle/>
@@ -9932,6 +10033,7 @@
           <a:lstStyle/>
           <a:p>
             <a:pPr algn="ctr"/>
+            <a:endParaRPr/>
           </a:p>
         </p:txBody>
       </p:sp>
@@ -9952,7 +10054,7 @@
           <a:noFill/>
         </p:spPr>
         <p:txBody>
-          <a:bodyPr wrap="square" lIns="0" rIns="0" tIns="0" bIns="0" anchor="ctr">
+          <a:bodyPr wrap="square" lIns="0" tIns="0" rIns="0" bIns="0" anchor="ctr">
             <a:spAutoFit/>
           </a:bodyPr>
           <a:lstStyle/>
@@ -9986,7 +10088,7 @@
           <a:noFill/>
         </p:spPr>
         <p:txBody>
-          <a:bodyPr wrap="square" lIns="0" rIns="0" tIns="0" bIns="0" anchor="ctr">
+          <a:bodyPr wrap="square" lIns="0" tIns="0" rIns="0" bIns="0" anchor="ctr">
             <a:spAutoFit/>
           </a:bodyPr>
           <a:lstStyle/>
@@ -10045,6 +10147,7 @@
           <a:lstStyle/>
           <a:p>
             <a:pPr algn="ctr"/>
+            <a:endParaRPr/>
           </a:p>
         </p:txBody>
       </p:sp>
@@ -10065,7 +10168,7 @@
           <a:noFill/>
         </p:spPr>
         <p:txBody>
-          <a:bodyPr wrap="square" lIns="0" rIns="0" tIns="0" bIns="0" anchor="ctr">
+          <a:bodyPr wrap="square" lIns="0" tIns="0" rIns="0" bIns="0" anchor="ctr">
             <a:spAutoFit/>
           </a:bodyPr>
           <a:lstStyle/>
@@ -10099,7 +10202,7 @@
           <a:noFill/>
         </p:spPr>
         <p:txBody>
-          <a:bodyPr wrap="square" lIns="0" rIns="0" tIns="0" bIns="0" anchor="ctr">
+          <a:bodyPr wrap="square" lIns="0" tIns="0" rIns="0" bIns="0" anchor="ctr">
             <a:spAutoFit/>
           </a:bodyPr>
           <a:lstStyle/>
@@ -10158,6 +10261,7 @@
           <a:lstStyle/>
           <a:p>
             <a:pPr algn="ctr"/>
+            <a:endParaRPr/>
           </a:p>
         </p:txBody>
       </p:sp>
@@ -10178,7 +10282,7 @@
           <a:noFill/>
         </p:spPr>
         <p:txBody>
-          <a:bodyPr wrap="square" lIns="0" rIns="0" tIns="0" bIns="0" anchor="ctr">
+          <a:bodyPr wrap="square" lIns="0" tIns="0" rIns="0" bIns="0" anchor="ctr">
             <a:spAutoFit/>
           </a:bodyPr>
           <a:lstStyle/>
@@ -10212,7 +10316,7 @@
           <a:noFill/>
         </p:spPr>
         <p:txBody>
-          <a:bodyPr wrap="square" lIns="0" rIns="0" tIns="0" bIns="0" anchor="ctr">
+          <a:bodyPr wrap="square" lIns="0" tIns="0" rIns="0" bIns="0" anchor="ctr">
             <a:spAutoFit/>
           </a:bodyPr>
           <a:lstStyle/>
@@ -10271,6 +10375,7 @@
           <a:lstStyle/>
           <a:p>
             <a:pPr algn="ctr"/>
+            <a:endParaRPr/>
           </a:p>
         </p:txBody>
       </p:sp>
@@ -10291,7 +10396,7 @@
           <a:noFill/>
         </p:spPr>
         <p:txBody>
-          <a:bodyPr wrap="square" lIns="0" rIns="0" tIns="0" bIns="0" anchor="ctr">
+          <a:bodyPr wrap="square" lIns="0" tIns="0" rIns="0" bIns="0" anchor="ctr">
             <a:spAutoFit/>
           </a:bodyPr>
           <a:lstStyle/>
@@ -10325,7 +10430,7 @@
           <a:noFill/>
         </p:spPr>
         <p:txBody>
-          <a:bodyPr wrap="square" lIns="0" rIns="0" tIns="0" bIns="0" anchor="ctr">
+          <a:bodyPr wrap="square" lIns="0" tIns="0" rIns="0" bIns="0" anchor="ctr">
             <a:spAutoFit/>
           </a:bodyPr>
           <a:lstStyle/>
@@ -10384,6 +10489,7 @@
           <a:lstStyle/>
           <a:p>
             <a:pPr algn="ctr"/>
+            <a:endParaRPr/>
           </a:p>
         </p:txBody>
       </p:sp>
@@ -10404,7 +10510,7 @@
           <a:noFill/>
         </p:spPr>
         <p:txBody>
-          <a:bodyPr wrap="square" lIns="0" rIns="0" tIns="0" bIns="0">
+          <a:bodyPr wrap="square" lIns="0" tIns="0" rIns="0" bIns="0">
             <a:spAutoFit/>
           </a:bodyPr>
           <a:lstStyle/>
@@ -10438,7 +10544,7 @@
           <a:noFill/>
         </p:spPr>
         <p:txBody>
-          <a:bodyPr wrap="square" lIns="0" rIns="0" tIns="0" bIns="0">
+          <a:bodyPr wrap="square" lIns="0" tIns="0" rIns="0" bIns="0">
             <a:spAutoFit/>
           </a:bodyPr>
           <a:lstStyle/>
@@ -10473,7 +10579,7 @@
           <a:noFill/>
         </p:spPr>
         <p:txBody>
-          <a:bodyPr wrap="square" lIns="0" rIns="0" tIns="0" bIns="0">
+          <a:bodyPr wrap="square" lIns="0" tIns="0" rIns="0" bIns="0">
             <a:spAutoFit/>
           </a:bodyPr>
           <a:lstStyle/>
@@ -10520,7 +10626,7 @@
           <a:noFill/>
         </p:spPr>
         <p:txBody>
-          <a:bodyPr wrap="square" lIns="0" rIns="0" tIns="0" bIns="0">
+          <a:bodyPr wrap="square" lIns="0" tIns="0" rIns="0" bIns="0">
             <a:spAutoFit/>
           </a:bodyPr>
           <a:lstStyle/>
@@ -10555,7 +10661,7 @@
           <a:noFill/>
         </p:spPr>
         <p:txBody>
-          <a:bodyPr wrap="square" lIns="0" rIns="0" tIns="0" bIns="0">
+          <a:bodyPr wrap="square" lIns="0" tIns="0" rIns="0" bIns="0">
             <a:spAutoFit/>
           </a:bodyPr>
           <a:lstStyle/>
@@ -10602,7 +10708,7 @@
           <a:noFill/>
         </p:spPr>
         <p:txBody>
-          <a:bodyPr wrap="square" lIns="0" rIns="0" tIns="0" bIns="0">
+          <a:bodyPr wrap="square" lIns="0" tIns="0" rIns="0" bIns="0">
             <a:spAutoFit/>
           </a:bodyPr>
           <a:lstStyle/>
@@ -10637,7 +10743,7 @@
           <a:noFill/>
         </p:spPr>
         <p:txBody>
-          <a:bodyPr wrap="square" lIns="0" rIns="0" tIns="0" bIns="0">
+          <a:bodyPr wrap="square" lIns="0" tIns="0" rIns="0" bIns="0">
             <a:spAutoFit/>
           </a:bodyPr>
           <a:lstStyle/>
@@ -10684,7 +10790,7 @@
           <a:noFill/>
         </p:spPr>
         <p:txBody>
-          <a:bodyPr wrap="square" lIns="0" rIns="0" tIns="0" bIns="0">
+          <a:bodyPr wrap="square" lIns="0" tIns="0" rIns="0" bIns="0">
             <a:spAutoFit/>
           </a:bodyPr>
           <a:lstStyle/>
@@ -10719,7 +10825,7 @@
           <a:noFill/>
         </p:spPr>
         <p:txBody>
-          <a:bodyPr wrap="square" lIns="0" rIns="0" tIns="0" bIns="0">
+          <a:bodyPr wrap="square" lIns="0" tIns="0" rIns="0" bIns="0">
             <a:spAutoFit/>
           </a:bodyPr>
           <a:lstStyle/>
@@ -10766,7 +10872,7 @@
           <a:noFill/>
         </p:spPr>
         <p:txBody>
-          <a:bodyPr wrap="square" lIns="0" rIns="0" tIns="0" bIns="0">
+          <a:bodyPr wrap="square" lIns="0" tIns="0" rIns="0" bIns="0">
             <a:spAutoFit/>
           </a:bodyPr>
           <a:lstStyle/>
@@ -10801,7 +10907,7 @@
           <a:noFill/>
         </p:spPr>
         <p:txBody>
-          <a:bodyPr wrap="square" lIns="0" rIns="0" tIns="0" bIns="0">
+          <a:bodyPr wrap="square" lIns="0" tIns="0" rIns="0" bIns="0">
             <a:spAutoFit/>
           </a:bodyPr>
           <a:lstStyle/>
@@ -10848,7 +10954,7 @@
           <a:noFill/>
         </p:spPr>
         <p:txBody>
-          <a:bodyPr wrap="square" lIns="0" rIns="0" tIns="0" bIns="0">
+          <a:bodyPr wrap="square" lIns="0" tIns="0" rIns="0" bIns="0">
             <a:spAutoFit/>
           </a:bodyPr>
           <a:lstStyle/>
@@ -10882,7 +10988,7 @@
           <a:noFill/>
         </p:spPr>
         <p:txBody>
-          <a:bodyPr wrap="square" lIns="0" rIns="0" tIns="0" bIns="0">
+          <a:bodyPr wrap="square" lIns="0" tIns="0" rIns="0" bIns="0">
             <a:spAutoFit/>
           </a:bodyPr>
           <a:lstStyle/>
@@ -10909,7 +11015,7 @@
 </file>
 
 <file path=ppt/slides/slide6.xml><?xml version="1.0" encoding="utf-8"?>
-<p:sld xmlns:a="http://schemas.openxmlformats.org/drawingml/2006/main" xmlns:p="http://schemas.openxmlformats.org/presentationml/2006/main" xmlns:r="http://schemas.openxmlformats.org/officeDocument/2006/relationships">
+<p:sld xmlns:a="http://schemas.openxmlformats.org/drawingml/2006/main" xmlns:r="http://schemas.openxmlformats.org/officeDocument/2006/relationships" xmlns:p="http://schemas.openxmlformats.org/presentationml/2006/main">
   <p:cSld>
     <p:spTree>
       <p:nvGrpSpPr>
@@ -10917,7 +11023,14 @@
         <p:cNvGrpSpPr/>
         <p:nvPr/>
       </p:nvGrpSpPr>
-      <p:grpSpPr/>
+      <p:grpSpPr>
+        <a:xfrm>
+          <a:off x="0" y="0"/>
+          <a:ext cx="0" cy="0"/>
+          <a:chOff x="0" y="0"/>
+          <a:chExt cx="0" cy="0"/>
+        </a:xfrm>
+      </p:grpSpPr>
       <p:sp>
         <p:nvSpPr>
           <p:cNvPr id="2" name="Rectangle 1"/>
@@ -10958,6 +11071,7 @@
           <a:lstStyle/>
           <a:p>
             <a:pPr algn="ctr"/>
+            <a:endParaRPr/>
           </a:p>
         </p:txBody>
       </p:sp>
@@ -11001,6 +11115,7 @@
           <a:lstStyle/>
           <a:p>
             <a:pPr algn="ctr"/>
+            <a:endParaRPr/>
           </a:p>
         </p:txBody>
       </p:sp>
@@ -11021,7 +11136,7 @@
           <a:noFill/>
         </p:spPr>
         <p:txBody>
-          <a:bodyPr wrap="square" lIns="0" rIns="0" tIns="0" bIns="0">
+          <a:bodyPr wrap="square" lIns="0" tIns="0" rIns="0" bIns="0">
             <a:spAutoFit/>
           </a:bodyPr>
           <a:lstStyle/>
@@ -11055,7 +11170,7 @@
           <a:noFill/>
         </p:spPr>
         <p:txBody>
-          <a:bodyPr wrap="square" lIns="0" rIns="0" tIns="0" bIns="0">
+          <a:bodyPr wrap="square" lIns="0" tIns="0" rIns="0" bIns="0">
             <a:spAutoFit/>
           </a:bodyPr>
           <a:lstStyle/>
@@ -11112,6 +11227,7 @@
           <a:lstStyle/>
           <a:p>
             <a:pPr algn="ctr"/>
+            <a:endParaRPr/>
           </a:p>
         </p:txBody>
       </p:sp>
@@ -11132,7 +11248,7 @@
           <a:noFill/>
         </p:spPr>
         <p:txBody>
-          <a:bodyPr wrap="square" lIns="0" rIns="0" tIns="0" bIns="0">
+          <a:bodyPr wrap="square" lIns="0" tIns="0" rIns="0" bIns="0">
             <a:spAutoFit/>
           </a:bodyPr>
           <a:lstStyle/>
@@ -11166,7 +11282,7 @@
           <a:noFill/>
         </p:spPr>
         <p:txBody>
-          <a:bodyPr wrap="square" lIns="0" rIns="0" tIns="0" bIns="0">
+          <a:bodyPr wrap="square" lIns="0" tIns="0" rIns="0" bIns="0">
             <a:spAutoFit/>
           </a:bodyPr>
           <a:lstStyle/>
@@ -11200,7 +11316,7 @@
           <a:noFill/>
         </p:spPr>
         <p:txBody>
-          <a:bodyPr wrap="square" lIns="0" rIns="0" tIns="0" bIns="0">
+          <a:bodyPr wrap="square" lIns="0" tIns="0" rIns="0" bIns="0">
             <a:spAutoFit/>
           </a:bodyPr>
           <a:lstStyle/>
@@ -11234,7 +11350,7 @@
           <a:noFill/>
         </p:spPr>
         <p:txBody>
-          <a:bodyPr wrap="square" lIns="0" rIns="0" tIns="0" bIns="0">
+          <a:bodyPr wrap="square" lIns="0" tIns="0" rIns="0" bIns="0">
             <a:spAutoFit/>
           </a:bodyPr>
           <a:lstStyle/>
@@ -11302,6 +11418,7 @@
           <a:lstStyle/>
           <a:p>
             <a:pPr algn="ctr"/>
+            <a:endParaRPr/>
           </a:p>
         </p:txBody>
       </p:sp>
@@ -11322,7 +11439,7 @@
           <a:noFill/>
         </p:spPr>
         <p:txBody>
-          <a:bodyPr wrap="square" lIns="0" rIns="0" tIns="0" bIns="0">
+          <a:bodyPr wrap="square" lIns="0" tIns="0" rIns="0" bIns="0">
             <a:spAutoFit/>
           </a:bodyPr>
           <a:lstStyle/>
@@ -11356,7 +11473,7 @@
           <a:noFill/>
         </p:spPr>
         <p:txBody>
-          <a:bodyPr wrap="square" lIns="0" rIns="0" tIns="0" bIns="0">
+          <a:bodyPr wrap="square" lIns="0" tIns="0" rIns="0" bIns="0">
             <a:spAutoFit/>
           </a:bodyPr>
           <a:lstStyle/>
@@ -11390,7 +11507,7 @@
           <a:noFill/>
         </p:spPr>
         <p:txBody>
-          <a:bodyPr wrap="square" lIns="0" rIns="0" tIns="0" bIns="0">
+          <a:bodyPr wrap="square" lIns="0" tIns="0" rIns="0" bIns="0">
             <a:spAutoFit/>
           </a:bodyPr>
           <a:lstStyle/>
@@ -11424,7 +11541,7 @@
           <a:noFill/>
         </p:spPr>
         <p:txBody>
-          <a:bodyPr wrap="square" lIns="0" rIns="0" tIns="0" bIns="0">
+          <a:bodyPr wrap="square" lIns="0" tIns="0" rIns="0" bIns="0">
             <a:spAutoFit/>
           </a:bodyPr>
           <a:lstStyle/>
@@ -11481,6 +11598,7 @@
           <a:lstStyle/>
           <a:p>
             <a:pPr algn="ctr"/>
+            <a:endParaRPr/>
           </a:p>
         </p:txBody>
       </p:sp>
@@ -11524,6 +11642,7 @@
           <a:lstStyle/>
           <a:p>
             <a:pPr algn="ctr"/>
+            <a:endParaRPr/>
           </a:p>
         </p:txBody>
       </p:sp>
@@ -11544,7 +11663,7 @@
           <a:noFill/>
         </p:spPr>
         <p:txBody>
-          <a:bodyPr wrap="square" lIns="0" rIns="0" tIns="0" bIns="0" anchor="ctr">
+          <a:bodyPr wrap="square" lIns="0" tIns="0" rIns="0" bIns="0" anchor="ctr">
             <a:spAutoFit/>
           </a:bodyPr>
           <a:lstStyle/>
@@ -11579,7 +11698,7 @@
           <a:noFill/>
         </p:spPr>
         <p:txBody>
-          <a:bodyPr wrap="square" lIns="0" rIns="0" tIns="0" bIns="0">
+          <a:bodyPr wrap="square" lIns="0" tIns="0" rIns="0" bIns="0">
             <a:spAutoFit/>
           </a:bodyPr>
           <a:lstStyle/>
@@ -11613,7 +11732,7 @@
           <a:noFill/>
         </p:spPr>
         <p:txBody>
-          <a:bodyPr wrap="square" lIns="0" rIns="0" tIns="0" bIns="0">
+          <a:bodyPr wrap="square" lIns="0" tIns="0" rIns="0" bIns="0">
             <a:spAutoFit/>
           </a:bodyPr>
           <a:lstStyle/>
@@ -11647,7 +11766,7 @@
           <a:noFill/>
         </p:spPr>
         <p:txBody>
-          <a:bodyPr wrap="square" lIns="0" rIns="0" tIns="0" bIns="0">
+          <a:bodyPr wrap="square" lIns="0" tIns="0" rIns="0" bIns="0">
             <a:spAutoFit/>
           </a:bodyPr>
           <a:lstStyle/>
@@ -11681,7 +11800,7 @@
           <a:noFill/>
         </p:spPr>
         <p:txBody>
-          <a:bodyPr wrap="square" lIns="0" rIns="0" tIns="0" bIns="0">
+          <a:bodyPr wrap="square" lIns="0" tIns="0" rIns="0" bIns="0">
             <a:spAutoFit/>
           </a:bodyPr>
           <a:lstStyle/>
@@ -11749,6 +11868,7 @@
           <a:lstStyle/>
           <a:p>
             <a:pPr algn="ctr"/>
+            <a:endParaRPr/>
           </a:p>
         </p:txBody>
       </p:sp>
@@ -11769,7 +11889,7 @@
           <a:noFill/>
         </p:spPr>
         <p:txBody>
-          <a:bodyPr wrap="square" lIns="0" rIns="0" tIns="0" bIns="0">
+          <a:bodyPr wrap="square" lIns="0" tIns="0" rIns="0" bIns="0">
             <a:spAutoFit/>
           </a:bodyPr>
           <a:lstStyle/>
@@ -11803,7 +11923,7 @@
           <a:noFill/>
         </p:spPr>
         <p:txBody>
-          <a:bodyPr wrap="square" lIns="0" rIns="0" tIns="0" bIns="0">
+          <a:bodyPr wrap="square" lIns="0" tIns="0" rIns="0" bIns="0">
             <a:spAutoFit/>
           </a:bodyPr>
           <a:lstStyle/>
@@ -11837,7 +11957,7 @@
           <a:noFill/>
         </p:spPr>
         <p:txBody>
-          <a:bodyPr wrap="square" lIns="0" rIns="0" tIns="0" bIns="0">
+          <a:bodyPr wrap="square" lIns="0" tIns="0" rIns="0" bIns="0">
             <a:spAutoFit/>
           </a:bodyPr>
           <a:lstStyle/>
@@ -11871,7 +11991,7 @@
           <a:noFill/>
         </p:spPr>
         <p:txBody>
-          <a:bodyPr wrap="square" lIns="0" rIns="0" tIns="0" bIns="0">
+          <a:bodyPr wrap="square" lIns="0" tIns="0" rIns="0" bIns="0">
             <a:spAutoFit/>
           </a:bodyPr>
           <a:lstStyle/>
@@ -11928,6 +12048,7 @@
           <a:lstStyle/>
           <a:p>
             <a:pPr algn="ctr"/>
+            <a:endParaRPr/>
           </a:p>
         </p:txBody>
       </p:sp>
@@ -11948,7 +12069,7 @@
           <a:noFill/>
         </p:spPr>
         <p:txBody>
-          <a:bodyPr wrap="square" lIns="0" rIns="0" tIns="0" bIns="0">
+          <a:bodyPr wrap="square" lIns="0" tIns="0" rIns="0" bIns="0">
             <a:spAutoFit/>
           </a:bodyPr>
           <a:lstStyle/>
@@ -11982,7 +12103,7 @@
           <a:noFill/>
         </p:spPr>
         <p:txBody>
-          <a:bodyPr wrap="square" lIns="0" rIns="0" tIns="0" bIns="0">
+          <a:bodyPr wrap="square" lIns="0" tIns="0" rIns="0" bIns="0">
             <a:spAutoFit/>
           </a:bodyPr>
           <a:lstStyle/>
@@ -12016,7 +12137,7 @@
           <a:noFill/>
         </p:spPr>
         <p:txBody>
-          <a:bodyPr wrap="square" lIns="0" rIns="0" tIns="0" bIns="0">
+          <a:bodyPr wrap="square" lIns="0" tIns="0" rIns="0" bIns="0">
             <a:spAutoFit/>
           </a:bodyPr>
           <a:lstStyle/>
@@ -12050,7 +12171,7 @@
           <a:noFill/>
         </p:spPr>
         <p:txBody>
-          <a:bodyPr wrap="square" lIns="0" rIns="0" tIns="0" bIns="0">
+          <a:bodyPr wrap="square" lIns="0" tIns="0" rIns="0" bIns="0">
             <a:spAutoFit/>
           </a:bodyPr>
           <a:lstStyle/>
@@ -12118,6 +12239,7 @@
           <a:lstStyle/>
           <a:p>
             <a:pPr algn="ctr"/>
+            <a:endParaRPr/>
           </a:p>
         </p:txBody>
       </p:sp>
@@ -12138,7 +12260,7 @@
           <a:noFill/>
         </p:spPr>
         <p:txBody>
-          <a:bodyPr wrap="square" lIns="0" rIns="0" tIns="0" bIns="0">
+          <a:bodyPr wrap="square" lIns="0" tIns="0" rIns="0" bIns="0">
             <a:spAutoFit/>
           </a:bodyPr>
           <a:lstStyle/>
@@ -12172,7 +12294,7 @@
           <a:noFill/>
         </p:spPr>
         <p:txBody>
-          <a:bodyPr wrap="square" lIns="0" rIns="0" tIns="0" bIns="0">
+          <a:bodyPr wrap="square" lIns="0" tIns="0" rIns="0" bIns="0">
             <a:spAutoFit/>
           </a:bodyPr>
           <a:lstStyle/>
@@ -12206,7 +12328,7 @@
           <a:noFill/>
         </p:spPr>
         <p:txBody>
-          <a:bodyPr wrap="square" lIns="0" rIns="0" tIns="0" bIns="0">
+          <a:bodyPr wrap="square" lIns="0" tIns="0" rIns="0" bIns="0">
             <a:spAutoFit/>
           </a:bodyPr>
           <a:lstStyle/>
@@ -12240,7 +12362,7 @@
           <a:noFill/>
         </p:spPr>
         <p:txBody>
-          <a:bodyPr wrap="square" lIns="0" rIns="0" tIns="0" bIns="0">
+          <a:bodyPr wrap="square" lIns="0" tIns="0" rIns="0" bIns="0">
             <a:spAutoFit/>
           </a:bodyPr>
           <a:lstStyle/>
@@ -12297,6 +12419,7 @@
           <a:lstStyle/>
           <a:p>
             <a:pPr algn="ctr"/>
+            <a:endParaRPr/>
           </a:p>
         </p:txBody>
       </p:sp>
@@ -12317,7 +12440,7 @@
           <a:noFill/>
         </p:spPr>
         <p:txBody>
-          <a:bodyPr wrap="square" lIns="0" rIns="0" tIns="0" bIns="0">
+          <a:bodyPr wrap="square" lIns="0" tIns="0" rIns="0" bIns="0">
             <a:spAutoFit/>
           </a:bodyPr>
           <a:lstStyle/>
@@ -12352,7 +12475,7 @@
           <a:noFill/>
         </p:spPr>
         <p:txBody>
-          <a:bodyPr wrap="square" lIns="0" rIns="0" tIns="0" bIns="0">
+          <a:bodyPr wrap="square" lIns="0" tIns="0" rIns="0" bIns="0">
             <a:spAutoFit/>
           </a:bodyPr>
           <a:lstStyle/>
@@ -12387,7 +12510,7 @@
           <a:noFill/>
         </p:spPr>
         <p:txBody>
-          <a:bodyPr wrap="square" lIns="0" rIns="0" tIns="0" bIns="0">
+          <a:bodyPr wrap="square" lIns="0" tIns="0" rIns="0" bIns="0">
             <a:spAutoFit/>
           </a:bodyPr>
           <a:lstStyle/>
@@ -12422,7 +12545,7 @@
           <a:noFill/>
         </p:spPr>
         <p:txBody>
-          <a:bodyPr wrap="square" lIns="0" rIns="0" tIns="0" bIns="0">
+          <a:bodyPr wrap="square" lIns="0" tIns="0" rIns="0" bIns="0">
             <a:spAutoFit/>
           </a:bodyPr>
           <a:lstStyle/>
@@ -12457,7 +12580,7 @@
           <a:noFill/>
         </p:spPr>
         <p:txBody>
-          <a:bodyPr wrap="square" lIns="0" rIns="0" tIns="0" bIns="0">
+          <a:bodyPr wrap="square" lIns="0" tIns="0" rIns="0" bIns="0">
             <a:spAutoFit/>
           </a:bodyPr>
           <a:lstStyle/>
@@ -12492,7 +12615,7 @@
           <a:noFill/>
         </p:spPr>
         <p:txBody>
-          <a:bodyPr wrap="square" lIns="0" rIns="0" tIns="0" bIns="0">
+          <a:bodyPr wrap="square" lIns="0" tIns="0" rIns="0" bIns="0">
             <a:spAutoFit/>
           </a:bodyPr>
           <a:lstStyle/>
@@ -12527,7 +12650,7 @@
           <a:noFill/>
         </p:spPr>
         <p:txBody>
-          <a:bodyPr wrap="square" lIns="0" rIns="0" tIns="0" bIns="0">
+          <a:bodyPr wrap="square" lIns="0" tIns="0" rIns="0" bIns="0">
             <a:spAutoFit/>
           </a:bodyPr>
           <a:lstStyle/>
@@ -12562,7 +12685,7 @@
           <a:noFill/>
         </p:spPr>
         <p:txBody>
-          <a:bodyPr wrap="square" lIns="0" rIns="0" tIns="0" bIns="0">
+          <a:bodyPr wrap="square" lIns="0" tIns="0" rIns="0" bIns="0">
             <a:spAutoFit/>
           </a:bodyPr>
           <a:lstStyle/>
@@ -12597,7 +12720,7 @@
           <a:noFill/>
         </p:spPr>
         <p:txBody>
-          <a:bodyPr wrap="square" lIns="0" rIns="0" tIns="0" bIns="0">
+          <a:bodyPr wrap="square" lIns="0" tIns="0" rIns="0" bIns="0">
             <a:spAutoFit/>
           </a:bodyPr>
           <a:lstStyle/>
@@ -12632,7 +12755,7 @@
           <a:noFill/>
         </p:spPr>
         <p:txBody>
-          <a:bodyPr wrap="square" lIns="0" rIns="0" tIns="0" bIns="0">
+          <a:bodyPr wrap="square" lIns="0" tIns="0" rIns="0" bIns="0">
             <a:spAutoFit/>
           </a:bodyPr>
           <a:lstStyle/>
@@ -12667,7 +12790,7 @@
           <a:noFill/>
         </p:spPr>
         <p:txBody>
-          <a:bodyPr wrap="square" lIns="0" rIns="0" tIns="0" bIns="0">
+          <a:bodyPr wrap="square" lIns="0" tIns="0" rIns="0" bIns="0">
             <a:spAutoFit/>
           </a:bodyPr>
           <a:lstStyle/>
@@ -12701,7 +12824,7 @@
           <a:noFill/>
         </p:spPr>
         <p:txBody>
-          <a:bodyPr wrap="square" lIns="0" rIns="0" tIns="0" bIns="0">
+          <a:bodyPr wrap="square" lIns="0" tIns="0" rIns="0" bIns="0">
             <a:spAutoFit/>
           </a:bodyPr>
           <a:lstStyle/>
@@ -12728,7 +12851,7 @@
 </file>
 
 <file path=ppt/slides/slide7.xml><?xml version="1.0" encoding="utf-8"?>
-<p:sld xmlns:a="http://schemas.openxmlformats.org/drawingml/2006/main" xmlns:p="http://schemas.openxmlformats.org/presentationml/2006/main" xmlns:r="http://schemas.openxmlformats.org/officeDocument/2006/relationships">
+<p:sld xmlns:a="http://schemas.openxmlformats.org/drawingml/2006/main" xmlns:r="http://schemas.openxmlformats.org/officeDocument/2006/relationships" xmlns:p="http://schemas.openxmlformats.org/presentationml/2006/main">
   <p:cSld>
     <p:spTree>
       <p:nvGrpSpPr>
@@ -12736,7 +12859,14 @@
         <p:cNvGrpSpPr/>
         <p:nvPr/>
       </p:nvGrpSpPr>
-      <p:grpSpPr/>
+      <p:grpSpPr>
+        <a:xfrm>
+          <a:off x="0" y="0"/>
+          <a:ext cx="0" cy="0"/>
+          <a:chOff x="0" y="0"/>
+          <a:chExt cx="0" cy="0"/>
+        </a:xfrm>
+      </p:grpSpPr>
       <p:sp>
         <p:nvSpPr>
           <p:cNvPr id="2" name="Rectangle 1"/>
@@ -12777,6 +12907,7 @@
           <a:lstStyle/>
           <a:p>
             <a:pPr algn="ctr"/>
+            <a:endParaRPr/>
           </a:p>
         </p:txBody>
       </p:sp>
@@ -12820,6 +12951,7 @@
           <a:lstStyle/>
           <a:p>
             <a:pPr algn="ctr"/>
+            <a:endParaRPr/>
           </a:p>
         </p:txBody>
       </p:sp>
@@ -12840,7 +12972,7 @@
           <a:noFill/>
         </p:spPr>
         <p:txBody>
-          <a:bodyPr wrap="square" lIns="0" rIns="0" tIns="0" bIns="0">
+          <a:bodyPr wrap="square" lIns="0" tIns="0" rIns="0" bIns="0">
             <a:spAutoFit/>
           </a:bodyPr>
           <a:lstStyle/>
@@ -12874,7 +13006,7 @@
           <a:noFill/>
         </p:spPr>
         <p:txBody>
-          <a:bodyPr wrap="square" lIns="0" rIns="0" tIns="0" bIns="0">
+          <a:bodyPr wrap="square" lIns="0" tIns="0" rIns="0" bIns="0">
             <a:spAutoFit/>
           </a:bodyPr>
           <a:lstStyle/>
@@ -12931,6 +13063,7 @@
           <a:lstStyle/>
           <a:p>
             <a:pPr algn="ctr"/>
+            <a:endParaRPr/>
           </a:p>
         </p:txBody>
       </p:sp>
@@ -12951,7 +13084,7 @@
           <a:noFill/>
         </p:spPr>
         <p:txBody>
-          <a:bodyPr wrap="square" lIns="0" rIns="0" tIns="0" bIns="0" anchor="ctr">
+          <a:bodyPr wrap="square" lIns="0" tIns="0" rIns="0" bIns="0" anchor="ctr">
             <a:spAutoFit/>
           </a:bodyPr>
           <a:lstStyle/>
@@ -12985,7 +13118,7 @@
           <a:noFill/>
         </p:spPr>
         <p:txBody>
-          <a:bodyPr wrap="square" lIns="0" rIns="0" tIns="0" bIns="0" anchor="ctr">
+          <a:bodyPr wrap="square" lIns="0" tIns="0" rIns="0" bIns="0" anchor="ctr">
             <a:spAutoFit/>
           </a:bodyPr>
           <a:lstStyle/>
@@ -13019,7 +13152,7 @@
           <a:noFill/>
         </p:spPr>
         <p:txBody>
-          <a:bodyPr wrap="square" lIns="0" rIns="0" tIns="0" bIns="0" anchor="ctr">
+          <a:bodyPr wrap="square" lIns="0" tIns="0" rIns="0" bIns="0" anchor="ctr">
             <a:spAutoFit/>
           </a:bodyPr>
           <a:lstStyle/>
@@ -13053,7 +13186,7 @@
           <a:noFill/>
         </p:spPr>
         <p:txBody>
-          <a:bodyPr wrap="square" lIns="0" rIns="0" tIns="0" bIns="0" anchor="ctr">
+          <a:bodyPr wrap="square" lIns="0" tIns="0" rIns="0" bIns="0" anchor="ctr">
             <a:spAutoFit/>
           </a:bodyPr>
           <a:lstStyle/>
@@ -13087,7 +13220,7 @@
           <a:noFill/>
         </p:spPr>
         <p:txBody>
-          <a:bodyPr wrap="square" lIns="0" rIns="0" tIns="0" bIns="0" anchor="ctr">
+          <a:bodyPr wrap="square" lIns="0" tIns="0" rIns="0" bIns="0" anchor="ctr">
             <a:spAutoFit/>
           </a:bodyPr>
           <a:lstStyle/>
@@ -13146,6 +13279,7 @@
           <a:lstStyle/>
           <a:p>
             <a:pPr algn="ctr"/>
+            <a:endParaRPr/>
           </a:p>
         </p:txBody>
       </p:sp>
@@ -13166,7 +13300,7 @@
           <a:noFill/>
         </p:spPr>
         <p:txBody>
-          <a:bodyPr wrap="square" lIns="0" rIns="0" tIns="0" bIns="0" anchor="ctr">
+          <a:bodyPr wrap="square" lIns="0" tIns="0" rIns="0" bIns="0" anchor="ctr">
             <a:spAutoFit/>
           </a:bodyPr>
           <a:lstStyle/>
@@ -13200,7 +13334,7 @@
           <a:noFill/>
         </p:spPr>
         <p:txBody>
-          <a:bodyPr wrap="square" lIns="0" rIns="0" tIns="0" bIns="0" anchor="ctr">
+          <a:bodyPr wrap="square" lIns="0" tIns="0" rIns="0" bIns="0" anchor="ctr">
             <a:spAutoFit/>
           </a:bodyPr>
           <a:lstStyle/>
@@ -13234,7 +13368,7 @@
           <a:noFill/>
         </p:spPr>
         <p:txBody>
-          <a:bodyPr wrap="square" lIns="0" rIns="0" tIns="0" bIns="0" anchor="ctr">
+          <a:bodyPr wrap="square" lIns="0" tIns="0" rIns="0" bIns="0" anchor="ctr">
             <a:spAutoFit/>
           </a:bodyPr>
           <a:lstStyle/>
@@ -13268,7 +13402,7 @@
           <a:noFill/>
         </p:spPr>
         <p:txBody>
-          <a:bodyPr wrap="square" lIns="0" rIns="0" tIns="0" bIns="0" anchor="ctr">
+          <a:bodyPr wrap="square" lIns="0" tIns="0" rIns="0" bIns="0" anchor="ctr">
             <a:spAutoFit/>
           </a:bodyPr>
           <a:lstStyle/>
@@ -13302,7 +13436,7 @@
           <a:noFill/>
         </p:spPr>
         <p:txBody>
-          <a:bodyPr wrap="square" lIns="0" rIns="0" tIns="0" bIns="0" anchor="ctr">
+          <a:bodyPr wrap="square" lIns="0" tIns="0" rIns="0" bIns="0" anchor="ctr">
             <a:spAutoFit/>
           </a:bodyPr>
           <a:lstStyle/>
@@ -13361,6 +13495,7 @@
           <a:lstStyle/>
           <a:p>
             <a:pPr algn="ctr"/>
+            <a:endParaRPr/>
           </a:p>
         </p:txBody>
       </p:sp>
@@ -13381,7 +13516,7 @@
           <a:noFill/>
         </p:spPr>
         <p:txBody>
-          <a:bodyPr wrap="square" lIns="0" rIns="0" tIns="0" bIns="0" anchor="ctr">
+          <a:bodyPr wrap="square" lIns="0" tIns="0" rIns="0" bIns="0" anchor="ctr">
             <a:spAutoFit/>
           </a:bodyPr>
           <a:lstStyle/>
@@ -13415,7 +13550,7 @@
           <a:noFill/>
         </p:spPr>
         <p:txBody>
-          <a:bodyPr wrap="square" lIns="0" rIns="0" tIns="0" bIns="0" anchor="ctr">
+          <a:bodyPr wrap="square" lIns="0" tIns="0" rIns="0" bIns="0" anchor="ctr">
             <a:spAutoFit/>
           </a:bodyPr>
           <a:lstStyle/>
@@ -13449,7 +13584,7 @@
           <a:noFill/>
         </p:spPr>
         <p:txBody>
-          <a:bodyPr wrap="square" lIns="0" rIns="0" tIns="0" bIns="0" anchor="ctr">
+          <a:bodyPr wrap="square" lIns="0" tIns="0" rIns="0" bIns="0" anchor="ctr">
             <a:spAutoFit/>
           </a:bodyPr>
           <a:lstStyle/>
@@ -13483,7 +13618,7 @@
           <a:noFill/>
         </p:spPr>
         <p:txBody>
-          <a:bodyPr wrap="square" lIns="0" rIns="0" tIns="0" bIns="0" anchor="ctr">
+          <a:bodyPr wrap="square" lIns="0" tIns="0" rIns="0" bIns="0" anchor="ctr">
             <a:spAutoFit/>
           </a:bodyPr>
           <a:lstStyle/>
@@ -13517,7 +13652,7 @@
           <a:noFill/>
         </p:spPr>
         <p:txBody>
-          <a:bodyPr wrap="square" lIns="0" rIns="0" tIns="0" bIns="0" anchor="ctr">
+          <a:bodyPr wrap="square" lIns="0" tIns="0" rIns="0" bIns="0" anchor="ctr">
             <a:spAutoFit/>
           </a:bodyPr>
           <a:lstStyle/>
@@ -13576,6 +13711,7 @@
           <a:lstStyle/>
           <a:p>
             <a:pPr algn="ctr"/>
+            <a:endParaRPr/>
           </a:p>
         </p:txBody>
       </p:sp>
@@ -13596,7 +13732,7 @@
           <a:noFill/>
         </p:spPr>
         <p:txBody>
-          <a:bodyPr wrap="square" lIns="0" rIns="0" tIns="0" bIns="0" anchor="ctr">
+          <a:bodyPr wrap="square" lIns="0" tIns="0" rIns="0" bIns="0" anchor="ctr">
             <a:spAutoFit/>
           </a:bodyPr>
           <a:lstStyle/>
@@ -13630,7 +13766,7 @@
           <a:noFill/>
         </p:spPr>
         <p:txBody>
-          <a:bodyPr wrap="square" lIns="0" rIns="0" tIns="0" bIns="0" anchor="ctr">
+          <a:bodyPr wrap="square" lIns="0" tIns="0" rIns="0" bIns="0" anchor="ctr">
             <a:spAutoFit/>
           </a:bodyPr>
           <a:lstStyle/>
@@ -13664,7 +13800,7 @@
           <a:noFill/>
         </p:spPr>
         <p:txBody>
-          <a:bodyPr wrap="square" lIns="0" rIns="0" tIns="0" bIns="0" anchor="ctr">
+          <a:bodyPr wrap="square" lIns="0" tIns="0" rIns="0" bIns="0" anchor="ctr">
             <a:spAutoFit/>
           </a:bodyPr>
           <a:lstStyle/>
@@ -13698,7 +13834,7 @@
           <a:noFill/>
         </p:spPr>
         <p:txBody>
-          <a:bodyPr wrap="square" lIns="0" rIns="0" tIns="0" bIns="0" anchor="ctr">
+          <a:bodyPr wrap="square" lIns="0" tIns="0" rIns="0" bIns="0" anchor="ctr">
             <a:spAutoFit/>
           </a:bodyPr>
           <a:lstStyle/>
@@ -13732,7 +13868,7 @@
           <a:noFill/>
         </p:spPr>
         <p:txBody>
-          <a:bodyPr wrap="square" lIns="0" rIns="0" tIns="0" bIns="0" anchor="ctr">
+          <a:bodyPr wrap="square" lIns="0" tIns="0" rIns="0" bIns="0" anchor="ctr">
             <a:spAutoFit/>
           </a:bodyPr>
           <a:lstStyle/>
@@ -13791,6 +13927,7 @@
           <a:lstStyle/>
           <a:p>
             <a:pPr algn="ctr"/>
+            <a:endParaRPr/>
           </a:p>
         </p:txBody>
       </p:sp>
@@ -13811,7 +13948,7 @@
           <a:noFill/>
         </p:spPr>
         <p:txBody>
-          <a:bodyPr wrap="square" lIns="0" rIns="0" tIns="0" bIns="0" anchor="ctr">
+          <a:bodyPr wrap="square" lIns="0" tIns="0" rIns="0" bIns="0" anchor="ctr">
             <a:spAutoFit/>
           </a:bodyPr>
           <a:lstStyle/>
@@ -13845,7 +13982,7 @@
           <a:noFill/>
         </p:spPr>
         <p:txBody>
-          <a:bodyPr wrap="square" lIns="0" rIns="0" tIns="0" bIns="0" anchor="ctr">
+          <a:bodyPr wrap="square" lIns="0" tIns="0" rIns="0" bIns="0" anchor="ctr">
             <a:spAutoFit/>
           </a:bodyPr>
           <a:lstStyle/>
@@ -13879,7 +14016,7 @@
           <a:noFill/>
         </p:spPr>
         <p:txBody>
-          <a:bodyPr wrap="square" lIns="0" rIns="0" tIns="0" bIns="0" anchor="ctr">
+          <a:bodyPr wrap="square" lIns="0" tIns="0" rIns="0" bIns="0" anchor="ctr">
             <a:spAutoFit/>
           </a:bodyPr>
           <a:lstStyle/>
@@ -13913,7 +14050,7 @@
           <a:noFill/>
         </p:spPr>
         <p:txBody>
-          <a:bodyPr wrap="square" lIns="0" rIns="0" tIns="0" bIns="0" anchor="ctr">
+          <a:bodyPr wrap="square" lIns="0" tIns="0" rIns="0" bIns="0" anchor="ctr">
             <a:spAutoFit/>
           </a:bodyPr>
           <a:lstStyle/>
@@ -13947,7 +14084,7 @@
           <a:noFill/>
         </p:spPr>
         <p:txBody>
-          <a:bodyPr wrap="square" lIns="0" rIns="0" tIns="0" bIns="0" anchor="ctr">
+          <a:bodyPr wrap="square" lIns="0" tIns="0" rIns="0" bIns="0" anchor="ctr">
             <a:spAutoFit/>
           </a:bodyPr>
           <a:lstStyle/>
@@ -14006,6 +14143,7 @@
           <a:lstStyle/>
           <a:p>
             <a:pPr algn="ctr"/>
+            <a:endParaRPr/>
           </a:p>
         </p:txBody>
       </p:sp>
@@ -14026,7 +14164,7 @@
           <a:noFill/>
         </p:spPr>
         <p:txBody>
-          <a:bodyPr wrap="square" lIns="0" rIns="0" tIns="0" bIns="0" anchor="ctr">
+          <a:bodyPr wrap="square" lIns="0" tIns="0" rIns="0" bIns="0" anchor="ctr">
             <a:spAutoFit/>
           </a:bodyPr>
           <a:lstStyle/>
@@ -14060,7 +14198,7 @@
           <a:noFill/>
         </p:spPr>
         <p:txBody>
-          <a:bodyPr wrap="square" lIns="0" rIns="0" tIns="0" bIns="0" anchor="ctr">
+          <a:bodyPr wrap="square" lIns="0" tIns="0" rIns="0" bIns="0" anchor="ctr">
             <a:spAutoFit/>
           </a:bodyPr>
           <a:lstStyle/>
@@ -14094,7 +14232,7 @@
           <a:noFill/>
         </p:spPr>
         <p:txBody>
-          <a:bodyPr wrap="square" lIns="0" rIns="0" tIns="0" bIns="0" anchor="ctr">
+          <a:bodyPr wrap="square" lIns="0" tIns="0" rIns="0" bIns="0" anchor="ctr">
             <a:spAutoFit/>
           </a:bodyPr>
           <a:lstStyle/>
@@ -14128,7 +14266,7 @@
           <a:noFill/>
         </p:spPr>
         <p:txBody>
-          <a:bodyPr wrap="square" lIns="0" rIns="0" tIns="0" bIns="0" anchor="ctr">
+          <a:bodyPr wrap="square" lIns="0" tIns="0" rIns="0" bIns="0" anchor="ctr">
             <a:spAutoFit/>
           </a:bodyPr>
           <a:lstStyle/>
@@ -14162,7 +14300,7 @@
           <a:noFill/>
         </p:spPr>
         <p:txBody>
-          <a:bodyPr wrap="square" lIns="0" rIns="0" tIns="0" bIns="0" anchor="ctr">
+          <a:bodyPr wrap="square" lIns="0" tIns="0" rIns="0" bIns="0" anchor="ctr">
             <a:spAutoFit/>
           </a:bodyPr>
           <a:lstStyle/>
@@ -14221,6 +14359,7 @@
           <a:lstStyle/>
           <a:p>
             <a:pPr algn="ctr"/>
+            <a:endParaRPr/>
           </a:p>
         </p:txBody>
       </p:sp>
@@ -14241,7 +14380,7 @@
           <a:noFill/>
         </p:spPr>
         <p:txBody>
-          <a:bodyPr wrap="square" lIns="0" rIns="0" tIns="0" bIns="0" anchor="ctr">
+          <a:bodyPr wrap="square" lIns="0" tIns="0" rIns="0" bIns="0" anchor="ctr">
             <a:spAutoFit/>
           </a:bodyPr>
           <a:lstStyle/>
@@ -14275,7 +14414,7 @@
           <a:noFill/>
         </p:spPr>
         <p:txBody>
-          <a:bodyPr wrap="square" lIns="0" rIns="0" tIns="0" bIns="0" anchor="ctr">
+          <a:bodyPr wrap="square" lIns="0" tIns="0" rIns="0" bIns="0" anchor="ctr">
             <a:spAutoFit/>
           </a:bodyPr>
           <a:lstStyle/>
@@ -14309,7 +14448,7 @@
           <a:noFill/>
         </p:spPr>
         <p:txBody>
-          <a:bodyPr wrap="square" lIns="0" rIns="0" tIns="0" bIns="0" anchor="ctr">
+          <a:bodyPr wrap="square" lIns="0" tIns="0" rIns="0" bIns="0" anchor="ctr">
             <a:spAutoFit/>
           </a:bodyPr>
           <a:lstStyle/>
@@ -14343,7 +14482,7 @@
           <a:noFill/>
         </p:spPr>
         <p:txBody>
-          <a:bodyPr wrap="square" lIns="0" rIns="0" tIns="0" bIns="0" anchor="ctr">
+          <a:bodyPr wrap="square" lIns="0" tIns="0" rIns="0" bIns="0" anchor="ctr">
             <a:spAutoFit/>
           </a:bodyPr>
           <a:lstStyle/>
@@ -14377,7 +14516,7 @@
           <a:noFill/>
         </p:spPr>
         <p:txBody>
-          <a:bodyPr wrap="square" lIns="0" rIns="0" tIns="0" bIns="0" anchor="ctr">
+          <a:bodyPr wrap="square" lIns="0" tIns="0" rIns="0" bIns="0" anchor="ctr">
             <a:spAutoFit/>
           </a:bodyPr>
           <a:lstStyle/>
@@ -14411,7 +14550,7 @@
           <a:noFill/>
         </p:spPr>
         <p:txBody>
-          <a:bodyPr wrap="square" lIns="0" rIns="0" tIns="0" bIns="0">
+          <a:bodyPr wrap="square" lIns="0" tIns="0" rIns="0" bIns="0">
             <a:spAutoFit/>
           </a:bodyPr>
           <a:lstStyle/>
@@ -14468,6 +14607,7 @@
           <a:lstStyle/>
           <a:p>
             <a:pPr algn="ctr"/>
+            <a:endParaRPr/>
           </a:p>
         </p:txBody>
       </p:sp>
@@ -14488,7 +14628,7 @@
           <a:noFill/>
         </p:spPr>
         <p:txBody>
-          <a:bodyPr wrap="square" lIns="0" rIns="0" tIns="0" bIns="0" anchor="ctr">
+          <a:bodyPr wrap="square" lIns="0" tIns="0" rIns="0" bIns="0" anchor="ctr">
             <a:spAutoFit/>
           </a:bodyPr>
           <a:lstStyle/>
@@ -14546,6 +14686,7 @@
           <a:lstStyle/>
           <a:p>
             <a:pPr algn="ctr"/>
+            <a:endParaRPr/>
           </a:p>
         </p:txBody>
       </p:sp>
@@ -14566,7 +14707,7 @@
           <a:noFill/>
         </p:spPr>
         <p:txBody>
-          <a:bodyPr wrap="square" lIns="0" rIns="0" tIns="0" bIns="0" anchor="ctr">
+          <a:bodyPr wrap="square" lIns="0" tIns="0" rIns="0" bIns="0" anchor="ctr">
             <a:spAutoFit/>
           </a:bodyPr>
           <a:lstStyle/>
@@ -14624,6 +14765,7 @@
           <a:lstStyle/>
           <a:p>
             <a:pPr algn="ctr"/>
+            <a:endParaRPr/>
           </a:p>
         </p:txBody>
       </p:sp>
@@ -14644,7 +14786,7 @@
           <a:noFill/>
         </p:spPr>
         <p:txBody>
-          <a:bodyPr wrap="square" lIns="0" rIns="0" tIns="0" bIns="0" anchor="ctr">
+          <a:bodyPr wrap="square" lIns="0" tIns="0" rIns="0" bIns="0" anchor="ctr">
             <a:spAutoFit/>
           </a:bodyPr>
           <a:lstStyle/>
@@ -14702,6 +14844,7 @@
           <a:lstStyle/>
           <a:p>
             <a:pPr algn="ctr"/>
+            <a:endParaRPr/>
           </a:p>
         </p:txBody>
       </p:sp>
@@ -14722,7 +14865,7 @@
           <a:noFill/>
         </p:spPr>
         <p:txBody>
-          <a:bodyPr wrap="square" lIns="0" rIns="0" tIns="0" bIns="0" anchor="ctr">
+          <a:bodyPr wrap="square" lIns="0" tIns="0" rIns="0" bIns="0" anchor="ctr">
             <a:spAutoFit/>
           </a:bodyPr>
           <a:lstStyle/>
@@ -14757,7 +14900,7 @@
           <a:noFill/>
         </p:spPr>
         <p:txBody>
-          <a:bodyPr wrap="square" lIns="0" rIns="0" tIns="0" bIns="0">
+          <a:bodyPr wrap="square" lIns="0" tIns="0" rIns="0" bIns="0">
             <a:spAutoFit/>
           </a:bodyPr>
           <a:lstStyle/>
@@ -14791,7 +14934,7 @@
           <a:noFill/>
         </p:spPr>
         <p:txBody>
-          <a:bodyPr wrap="square" lIns="0" rIns="0" tIns="0" bIns="0">
+          <a:bodyPr wrap="square" lIns="0" tIns="0" rIns="0" bIns="0">
             <a:spAutoFit/>
           </a:bodyPr>
           <a:lstStyle/>
@@ -14818,7 +14961,7 @@
 </file>
 
 <file path=ppt/slides/slide8.xml><?xml version="1.0" encoding="utf-8"?>
-<p:sld xmlns:a="http://schemas.openxmlformats.org/drawingml/2006/main" xmlns:p="http://schemas.openxmlformats.org/presentationml/2006/main" xmlns:r="http://schemas.openxmlformats.org/officeDocument/2006/relationships">
+<p:sld xmlns:a="http://schemas.openxmlformats.org/drawingml/2006/main" xmlns:r="http://schemas.openxmlformats.org/officeDocument/2006/relationships" xmlns:p="http://schemas.openxmlformats.org/presentationml/2006/main">
   <p:cSld>
     <p:spTree>
       <p:nvGrpSpPr>
@@ -14826,7 +14969,14 @@
         <p:cNvGrpSpPr/>
         <p:nvPr/>
       </p:nvGrpSpPr>
-      <p:grpSpPr/>
+      <p:grpSpPr>
+        <a:xfrm>
+          <a:off x="0" y="0"/>
+          <a:ext cx="0" cy="0"/>
+          <a:chOff x="0" y="0"/>
+          <a:chExt cx="0" cy="0"/>
+        </a:xfrm>
+      </p:grpSpPr>
       <p:sp>
         <p:nvSpPr>
           <p:cNvPr id="2" name="Rectangle 1"/>
@@ -14867,6 +15017,7 @@
           <a:lstStyle/>
           <a:p>
             <a:pPr algn="ctr"/>
+            <a:endParaRPr/>
           </a:p>
         </p:txBody>
       </p:sp>
@@ -14910,6 +15061,7 @@
           <a:lstStyle/>
           <a:p>
             <a:pPr algn="ctr"/>
+            <a:endParaRPr/>
           </a:p>
         </p:txBody>
       </p:sp>
@@ -14930,7 +15082,7 @@
           <a:noFill/>
         </p:spPr>
         <p:txBody>
-          <a:bodyPr wrap="square" lIns="0" rIns="0" tIns="0" bIns="0">
+          <a:bodyPr wrap="square" lIns="0" tIns="0" rIns="0" bIns="0">
             <a:spAutoFit/>
           </a:bodyPr>
           <a:lstStyle/>
@@ -14964,7 +15116,7 @@
           <a:noFill/>
         </p:spPr>
         <p:txBody>
-          <a:bodyPr wrap="square" lIns="0" rIns="0" tIns="0" bIns="0">
+          <a:bodyPr wrap="square" lIns="0" tIns="0" rIns="0" bIns="0">
             <a:spAutoFit/>
           </a:bodyPr>
           <a:lstStyle/>
@@ -15023,6 +15175,7 @@
           <a:lstStyle/>
           <a:p>
             <a:pPr algn="ctr"/>
+            <a:endParaRPr/>
           </a:p>
         </p:txBody>
       </p:sp>
@@ -15043,7 +15196,7 @@
           <a:noFill/>
         </p:spPr>
         <p:txBody>
-          <a:bodyPr wrap="square" lIns="0" rIns="0" tIns="0" bIns="0">
+          <a:bodyPr wrap="square" lIns="0" tIns="0" rIns="0" bIns="0">
             <a:spAutoFit/>
           </a:bodyPr>
           <a:lstStyle/>
@@ -15100,6 +15253,7 @@
           <a:lstStyle/>
           <a:p>
             <a:pPr algn="ctr"/>
+            <a:endParaRPr/>
           </a:p>
         </p:txBody>
       </p:sp>
@@ -15120,7 +15274,7 @@
           <a:noFill/>
         </p:spPr>
         <p:txBody>
-          <a:bodyPr wrap="square" lIns="0" rIns="0" tIns="0" bIns="0" anchor="ctr">
+          <a:bodyPr wrap="square" lIns="0" tIns="0" rIns="0" bIns="0" anchor="ctr">
             <a:spAutoFit/>
           </a:bodyPr>
           <a:lstStyle/>
@@ -15155,7 +15309,7 @@
           <a:noFill/>
         </p:spPr>
         <p:txBody>
-          <a:bodyPr wrap="square" lIns="0" rIns="0" tIns="0" bIns="0" anchor="ctr">
+          <a:bodyPr wrap="square" lIns="0" tIns="0" rIns="0" bIns="0" anchor="ctr">
             <a:spAutoFit/>
           </a:bodyPr>
           <a:lstStyle/>
@@ -15212,6 +15366,7 @@
           <a:lstStyle/>
           <a:p>
             <a:pPr algn="ctr"/>
+            <a:endParaRPr/>
           </a:p>
         </p:txBody>
       </p:sp>
@@ -15232,7 +15387,7 @@
           <a:noFill/>
         </p:spPr>
         <p:txBody>
-          <a:bodyPr wrap="square" lIns="0" rIns="0" tIns="0" bIns="0" anchor="ctr">
+          <a:bodyPr wrap="square" lIns="0" tIns="0" rIns="0" bIns="0" anchor="ctr">
             <a:spAutoFit/>
           </a:bodyPr>
           <a:lstStyle/>
@@ -15267,7 +15422,7 @@
           <a:noFill/>
         </p:spPr>
         <p:txBody>
-          <a:bodyPr wrap="square" lIns="0" rIns="0" tIns="0" bIns="0" anchor="ctr">
+          <a:bodyPr wrap="square" lIns="0" tIns="0" rIns="0" bIns="0" anchor="ctr">
             <a:spAutoFit/>
           </a:bodyPr>
           <a:lstStyle/>
@@ -15324,6 +15479,7 @@
           <a:lstStyle/>
           <a:p>
             <a:pPr algn="ctr"/>
+            <a:endParaRPr/>
           </a:p>
         </p:txBody>
       </p:sp>
@@ -15344,7 +15500,7 @@
           <a:noFill/>
         </p:spPr>
         <p:txBody>
-          <a:bodyPr wrap="square" lIns="0" rIns="0" tIns="0" bIns="0" anchor="ctr">
+          <a:bodyPr wrap="square" lIns="0" tIns="0" rIns="0" bIns="0" anchor="ctr">
             <a:spAutoFit/>
           </a:bodyPr>
           <a:lstStyle/>
@@ -15379,7 +15535,7 @@
           <a:noFill/>
         </p:spPr>
         <p:txBody>
-          <a:bodyPr wrap="square" lIns="0" rIns="0" tIns="0" bIns="0" anchor="ctr">
+          <a:bodyPr wrap="square" lIns="0" tIns="0" rIns="0" bIns="0" anchor="ctr">
             <a:spAutoFit/>
           </a:bodyPr>
           <a:lstStyle/>
@@ -15436,6 +15592,7 @@
           <a:lstStyle/>
           <a:p>
             <a:pPr algn="ctr"/>
+            <a:endParaRPr/>
           </a:p>
         </p:txBody>
       </p:sp>
@@ -15456,7 +15613,7 @@
           <a:noFill/>
         </p:spPr>
         <p:txBody>
-          <a:bodyPr wrap="square" lIns="0" rIns="0" tIns="0" bIns="0" anchor="ctr">
+          <a:bodyPr wrap="square" lIns="0" tIns="0" rIns="0" bIns="0" anchor="ctr">
             <a:spAutoFit/>
           </a:bodyPr>
           <a:lstStyle/>
@@ -15491,7 +15648,7 @@
           <a:noFill/>
         </p:spPr>
         <p:txBody>
-          <a:bodyPr wrap="square" lIns="0" rIns="0" tIns="0" bIns="0" anchor="ctr">
+          <a:bodyPr wrap="square" lIns="0" tIns="0" rIns="0" bIns="0" anchor="ctr">
             <a:spAutoFit/>
           </a:bodyPr>
           <a:lstStyle/>
@@ -15548,6 +15705,7 @@
           <a:lstStyle/>
           <a:p>
             <a:pPr algn="ctr"/>
+            <a:endParaRPr/>
           </a:p>
         </p:txBody>
       </p:sp>
@@ -15568,7 +15726,7 @@
           <a:noFill/>
         </p:spPr>
         <p:txBody>
-          <a:bodyPr wrap="square" lIns="0" rIns="0" tIns="0" bIns="0" anchor="ctr">
+          <a:bodyPr wrap="square" lIns="0" tIns="0" rIns="0" bIns="0" anchor="ctr">
             <a:spAutoFit/>
           </a:bodyPr>
           <a:lstStyle/>
@@ -15603,7 +15761,7 @@
           <a:noFill/>
         </p:spPr>
         <p:txBody>
-          <a:bodyPr wrap="square" lIns="0" rIns="0" tIns="0" bIns="0" anchor="ctr">
+          <a:bodyPr wrap="square" lIns="0" tIns="0" rIns="0" bIns="0" anchor="ctr">
             <a:spAutoFit/>
           </a:bodyPr>
           <a:lstStyle/>
@@ -15615,7 +15773,7 @@
                 </a:solidFill>
                 <a:latin typeface="Calibri"/>
               </a:rPr>
-              <a:t>Brand identity finalized (EnergyLens Emerald Pulse)</a:t>
+              <a:t>Domain energylens.eu registered + 3 parallel Fabric data paths</a:t>
             </a:r>
           </a:p>
         </p:txBody>
@@ -15660,6 +15818,7 @@
           <a:lstStyle/>
           <a:p>
             <a:pPr algn="ctr"/>
+            <a:endParaRPr/>
           </a:p>
         </p:txBody>
       </p:sp>
@@ -15680,7 +15839,7 @@
           <a:noFill/>
         </p:spPr>
         <p:txBody>
-          <a:bodyPr wrap="square" lIns="0" rIns="0" tIns="0" bIns="0" anchor="ctr">
+          <a:bodyPr wrap="square" lIns="0" tIns="0" rIns="0" bIns="0" anchor="ctr">
             <a:spAutoFit/>
           </a:bodyPr>
           <a:lstStyle/>
@@ -15715,7 +15874,7 @@
           <a:noFill/>
         </p:spPr>
         <p:txBody>
-          <a:bodyPr wrap="square" lIns="0" rIns="0" tIns="0" bIns="0" anchor="ctr">
+          <a:bodyPr wrap="square" lIns="0" tIns="0" rIns="0" bIns="0" anchor="ctr">
             <a:spAutoFit/>
           </a:bodyPr>
           <a:lstStyle/>
@@ -15772,6 +15931,7 @@
           <a:lstStyle/>
           <a:p>
             <a:pPr algn="ctr"/>
+            <a:endParaRPr/>
           </a:p>
         </p:txBody>
       </p:sp>
@@ -15792,7 +15952,7 @@
           <a:noFill/>
         </p:spPr>
         <p:txBody>
-          <a:bodyPr wrap="square" lIns="0" rIns="0" tIns="0" bIns="0" anchor="ctr">
+          <a:bodyPr wrap="square" lIns="0" tIns="0" rIns="0" bIns="0" anchor="ctr">
             <a:spAutoFit/>
           </a:bodyPr>
           <a:lstStyle/>
@@ -15827,7 +15987,7 @@
           <a:noFill/>
         </p:spPr>
         <p:txBody>
-          <a:bodyPr wrap="square" lIns="0" rIns="0" tIns="0" bIns="0" anchor="ctr">
+          <a:bodyPr wrap="square" lIns="0" tIns="0" rIns="0" bIns="0" anchor="ctr">
             <a:spAutoFit/>
           </a:bodyPr>
           <a:lstStyle/>
@@ -15884,6 +16044,7 @@
           <a:lstStyle/>
           <a:p>
             <a:pPr algn="ctr"/>
+            <a:endParaRPr/>
           </a:p>
         </p:txBody>
       </p:sp>
@@ -15904,7 +16065,7 @@
           <a:noFill/>
         </p:spPr>
         <p:txBody>
-          <a:bodyPr wrap="square" lIns="0" rIns="0" tIns="0" bIns="0" anchor="ctr">
+          <a:bodyPr wrap="square" lIns="0" tIns="0" rIns="0" bIns="0" anchor="ctr">
             <a:spAutoFit/>
           </a:bodyPr>
           <a:lstStyle/>
@@ -15939,7 +16100,7 @@
           <a:noFill/>
         </p:spPr>
         <p:txBody>
-          <a:bodyPr wrap="square" lIns="0" rIns="0" tIns="0" bIns="0" anchor="ctr">
+          <a:bodyPr wrap="square" lIns="0" tIns="0" rIns="0" bIns="0" anchor="ctr">
             <a:spAutoFit/>
           </a:bodyPr>
           <a:lstStyle/>
@@ -15996,6 +16157,7 @@
           <a:lstStyle/>
           <a:p>
             <a:pPr algn="ctr"/>
+            <a:endParaRPr/>
           </a:p>
         </p:txBody>
       </p:sp>
@@ -16016,7 +16178,7 @@
           <a:noFill/>
         </p:spPr>
         <p:txBody>
-          <a:bodyPr wrap="square" lIns="0" rIns="0" tIns="0" bIns="0" anchor="ctr">
+          <a:bodyPr wrap="square" lIns="0" tIns="0" rIns="0" bIns="0" anchor="ctr">
             <a:spAutoFit/>
           </a:bodyPr>
           <a:lstStyle/>
@@ -16051,7 +16213,7 @@
           <a:noFill/>
         </p:spPr>
         <p:txBody>
-          <a:bodyPr wrap="square" lIns="0" rIns="0" tIns="0" bIns="0" anchor="ctr">
+          <a:bodyPr wrap="square" lIns="0" tIns="0" rIns="0" bIns="0" anchor="ctr">
             <a:spAutoFit/>
           </a:bodyPr>
           <a:lstStyle/>
@@ -16063,7 +16225,7 @@
                 </a:solidFill>
                 <a:latin typeface="Calibri"/>
               </a:rPr>
-              <a:t>IoT adapter framework design</a:t>
+              <a:t>AI Copilot live (LLM tool use, 6 tools, SSE streaming)</a:t>
             </a:r>
           </a:p>
         </p:txBody>
@@ -16108,6 +16270,7 @@
           <a:lstStyle/>
           <a:p>
             <a:pPr algn="ctr"/>
+            <a:endParaRPr/>
           </a:p>
         </p:txBody>
       </p:sp>
@@ -16128,7 +16291,7 @@
           <a:noFill/>
         </p:spPr>
         <p:txBody>
-          <a:bodyPr wrap="square" lIns="0" rIns="0" tIns="0" bIns="0" anchor="ctr">
+          <a:bodyPr wrap="square" lIns="0" tIns="0" rIns="0" bIns="0" anchor="ctr">
             <a:spAutoFit/>
           </a:bodyPr>
           <a:lstStyle/>
@@ -16163,7 +16326,7 @@
           <a:noFill/>
         </p:spPr>
         <p:txBody>
-          <a:bodyPr wrap="square" lIns="0" rIns="0" tIns="0" bIns="0" anchor="ctr">
+          <a:bodyPr wrap="square" lIns="0" tIns="0" rIns="0" bIns="0" anchor="ctr">
             <a:spAutoFit/>
           </a:bodyPr>
           <a:lstStyle/>
@@ -16175,7 +16338,7 @@
                 </a:solidFill>
                 <a:latin typeface="Calibri"/>
               </a:rPr>
-              <a:t>Microsoft DP-600 certification obtained</a:t>
+              <a:t>Web app v1 live (Next.js + FastAPI + Postgres, 3 auth providers)</a:t>
             </a:r>
           </a:p>
         </p:txBody>
@@ -16222,6 +16385,7 @@
           <a:lstStyle/>
           <a:p>
             <a:pPr algn="ctr"/>
+            <a:endParaRPr/>
           </a:p>
         </p:txBody>
       </p:sp>
@@ -16242,7 +16406,7 @@
           <a:noFill/>
         </p:spPr>
         <p:txBody>
-          <a:bodyPr wrap="square" lIns="0" rIns="0" tIns="0" bIns="0">
+          <a:bodyPr wrap="square" lIns="0" tIns="0" rIns="0" bIns="0">
             <a:spAutoFit/>
           </a:bodyPr>
           <a:lstStyle/>
@@ -16299,6 +16463,7 @@
           <a:lstStyle/>
           <a:p>
             <a:pPr algn="ctr"/>
+            <a:endParaRPr/>
           </a:p>
         </p:txBody>
       </p:sp>
@@ -16319,7 +16484,7 @@
           <a:noFill/>
         </p:spPr>
         <p:txBody>
-          <a:bodyPr wrap="square" lIns="0" rIns="0" tIns="0" bIns="0" anchor="ctr">
+          <a:bodyPr wrap="square" lIns="0" tIns="0" rIns="0" bIns="0" anchor="ctr">
             <a:spAutoFit/>
           </a:bodyPr>
           <a:lstStyle/>
@@ -16354,7 +16519,7 @@
           <a:noFill/>
         </p:spPr>
         <p:txBody>
-          <a:bodyPr wrap="square" lIns="0" rIns="0" tIns="0" bIns="0" anchor="ctr">
+          <a:bodyPr wrap="square" lIns="0" tIns="0" rIns="0" bIns="0" anchor="ctr">
             <a:spAutoFit/>
           </a:bodyPr>
           <a:lstStyle/>
@@ -16411,6 +16576,7 @@
           <a:lstStyle/>
           <a:p>
             <a:pPr algn="ctr"/>
+            <a:endParaRPr/>
           </a:p>
         </p:txBody>
       </p:sp>
@@ -16431,7 +16597,7 @@
           <a:noFill/>
         </p:spPr>
         <p:txBody>
-          <a:bodyPr wrap="square" lIns="0" rIns="0" tIns="0" bIns="0" anchor="ctr">
+          <a:bodyPr wrap="square" lIns="0" tIns="0" rIns="0" bIns="0" anchor="ctr">
             <a:spAutoFit/>
           </a:bodyPr>
           <a:lstStyle/>
@@ -16466,7 +16632,7 @@
           <a:noFill/>
         </p:spPr>
         <p:txBody>
-          <a:bodyPr wrap="square" lIns="0" rIns="0" tIns="0" bIns="0" anchor="ctr">
+          <a:bodyPr wrap="square" lIns="0" tIns="0" rIns="0" bIns="0" anchor="ctr">
             <a:spAutoFit/>
           </a:bodyPr>
           <a:lstStyle/>
@@ -16523,6 +16689,7 @@
           <a:lstStyle/>
           <a:p>
             <a:pPr algn="ctr"/>
+            <a:endParaRPr/>
           </a:p>
         </p:txBody>
       </p:sp>
@@ -16543,7 +16710,7 @@
           <a:noFill/>
         </p:spPr>
         <p:txBody>
-          <a:bodyPr wrap="square" lIns="0" rIns="0" tIns="0" bIns="0" anchor="ctr">
+          <a:bodyPr wrap="square" lIns="0" tIns="0" rIns="0" bIns="0" anchor="ctr">
             <a:spAutoFit/>
           </a:bodyPr>
           <a:lstStyle/>
@@ -16578,7 +16745,7 @@
           <a:noFill/>
         </p:spPr>
         <p:txBody>
-          <a:bodyPr wrap="square" lIns="0" rIns="0" tIns="0" bIns="0" anchor="ctr">
+          <a:bodyPr wrap="square" lIns="0" tIns="0" rIns="0" bIns="0" anchor="ctr">
             <a:spAutoFit/>
           </a:bodyPr>
           <a:lstStyle/>
@@ -16635,6 +16802,7 @@
           <a:lstStyle/>
           <a:p>
             <a:pPr algn="ctr"/>
+            <a:endParaRPr/>
           </a:p>
         </p:txBody>
       </p:sp>
@@ -16655,7 +16823,7 @@
           <a:noFill/>
         </p:spPr>
         <p:txBody>
-          <a:bodyPr wrap="square" lIns="0" rIns="0" tIns="0" bIns="0" anchor="ctr">
+          <a:bodyPr wrap="square" lIns="0" tIns="0" rIns="0" bIns="0" anchor="ctr">
             <a:spAutoFit/>
           </a:bodyPr>
           <a:lstStyle/>
@@ -16690,7 +16858,7 @@
           <a:noFill/>
         </p:spPr>
         <p:txBody>
-          <a:bodyPr wrap="square" lIns="0" rIns="0" tIns="0" bIns="0" anchor="ctr">
+          <a:bodyPr wrap="square" lIns="0" tIns="0" rIns="0" bIns="0" anchor="ctr">
             <a:spAutoFit/>
           </a:bodyPr>
           <a:lstStyle/>
@@ -16747,6 +16915,7 @@
           <a:lstStyle/>
           <a:p>
             <a:pPr algn="ctr"/>
+            <a:endParaRPr/>
           </a:p>
         </p:txBody>
       </p:sp>
@@ -16767,7 +16936,7 @@
           <a:noFill/>
         </p:spPr>
         <p:txBody>
-          <a:bodyPr wrap="square" lIns="0" rIns="0" tIns="0" bIns="0" anchor="ctr">
+          <a:bodyPr wrap="square" lIns="0" tIns="0" rIns="0" bIns="0" anchor="ctr">
             <a:spAutoFit/>
           </a:bodyPr>
           <a:lstStyle/>
@@ -16802,7 +16971,7 @@
           <a:noFill/>
         </p:spPr>
         <p:txBody>
-          <a:bodyPr wrap="square" lIns="0" rIns="0" tIns="0" bIns="0" anchor="ctr">
+          <a:bodyPr wrap="square" lIns="0" tIns="0" rIns="0" bIns="0" anchor="ctr">
             <a:spAutoFit/>
           </a:bodyPr>
           <a:lstStyle/>
@@ -16859,6 +17028,7 @@
           <a:lstStyle/>
           <a:p>
             <a:pPr algn="ctr"/>
+            <a:endParaRPr/>
           </a:p>
         </p:txBody>
       </p:sp>
@@ -16879,7 +17049,7 @@
           <a:noFill/>
         </p:spPr>
         <p:txBody>
-          <a:bodyPr wrap="square" lIns="0" rIns="0" tIns="0" bIns="0" anchor="ctr">
+          <a:bodyPr wrap="square" lIns="0" tIns="0" rIns="0" bIns="0" anchor="ctr">
             <a:spAutoFit/>
           </a:bodyPr>
           <a:lstStyle/>
@@ -16914,7 +17084,7 @@
           <a:noFill/>
         </p:spPr>
         <p:txBody>
-          <a:bodyPr wrap="square" lIns="0" rIns="0" tIns="0" bIns="0" anchor="ctr">
+          <a:bodyPr wrap="square" lIns="0" tIns="0" rIns="0" bIns="0" anchor="ctr">
             <a:spAutoFit/>
           </a:bodyPr>
           <a:lstStyle/>
@@ -16971,6 +17141,7 @@
           <a:lstStyle/>
           <a:p>
             <a:pPr algn="ctr"/>
+            <a:endParaRPr/>
           </a:p>
         </p:txBody>
       </p:sp>
@@ -16991,7 +17162,7 @@
           <a:noFill/>
         </p:spPr>
         <p:txBody>
-          <a:bodyPr wrap="square" lIns="0" rIns="0" tIns="0" bIns="0" anchor="ctr">
+          <a:bodyPr wrap="square" lIns="0" tIns="0" rIns="0" bIns="0" anchor="ctr">
             <a:spAutoFit/>
           </a:bodyPr>
           <a:lstStyle/>
@@ -17026,7 +17197,7 @@
           <a:noFill/>
         </p:spPr>
         <p:txBody>
-          <a:bodyPr wrap="square" lIns="0" rIns="0" tIns="0" bIns="0" anchor="ctr">
+          <a:bodyPr wrap="square" lIns="0" tIns="0" rIns="0" bIns="0" anchor="ctr">
             <a:spAutoFit/>
           </a:bodyPr>
           <a:lstStyle/>
@@ -17083,6 +17254,7 @@
           <a:lstStyle/>
           <a:p>
             <a:pPr algn="ctr"/>
+            <a:endParaRPr/>
           </a:p>
         </p:txBody>
       </p:sp>
@@ -17103,7 +17275,7 @@
           <a:noFill/>
         </p:spPr>
         <p:txBody>
-          <a:bodyPr wrap="square" lIns="0" rIns="0" tIns="0" bIns="0" anchor="ctr">
+          <a:bodyPr wrap="square" lIns="0" tIns="0" rIns="0" bIns="0" anchor="ctr">
             <a:spAutoFit/>
           </a:bodyPr>
           <a:lstStyle/>
@@ -17138,7 +17310,7 @@
           <a:noFill/>
         </p:spPr>
         <p:txBody>
-          <a:bodyPr wrap="square" lIns="0" rIns="0" tIns="0" bIns="0" anchor="ctr">
+          <a:bodyPr wrap="square" lIns="0" tIns="0" rIns="0" bIns="0" anchor="ctr">
             <a:spAutoFit/>
           </a:bodyPr>
           <a:lstStyle/>
@@ -17172,7 +17344,7 @@
           <a:noFill/>
         </p:spPr>
         <p:txBody>
-          <a:bodyPr wrap="square" lIns="0" rIns="0" tIns="0" bIns="0">
+          <a:bodyPr wrap="square" lIns="0" tIns="0" rIns="0" bIns="0">
             <a:spAutoFit/>
           </a:bodyPr>
           <a:lstStyle/>
@@ -17206,7 +17378,7 @@
           <a:noFill/>
         </p:spPr>
         <p:txBody>
-          <a:bodyPr wrap="square" lIns="0" rIns="0" tIns="0" bIns="0">
+          <a:bodyPr wrap="square" lIns="0" tIns="0" rIns="0" bIns="0">
             <a:spAutoFit/>
           </a:bodyPr>
           <a:lstStyle/>
@@ -17233,7 +17405,7 @@
 </file>
 
 <file path=ppt/slides/slide9.xml><?xml version="1.0" encoding="utf-8"?>
-<p:sld xmlns:a="http://schemas.openxmlformats.org/drawingml/2006/main" xmlns:p="http://schemas.openxmlformats.org/presentationml/2006/main" xmlns:r="http://schemas.openxmlformats.org/officeDocument/2006/relationships">
+<p:sld xmlns:a="http://schemas.openxmlformats.org/drawingml/2006/main" xmlns:r="http://schemas.openxmlformats.org/officeDocument/2006/relationships" xmlns:p="http://schemas.openxmlformats.org/presentationml/2006/main">
   <p:cSld>
     <p:spTree>
       <p:nvGrpSpPr>
@@ -17241,7 +17413,14 @@
         <p:cNvGrpSpPr/>
         <p:nvPr/>
       </p:nvGrpSpPr>
-      <p:grpSpPr/>
+      <p:grpSpPr>
+        <a:xfrm>
+          <a:off x="0" y="0"/>
+          <a:ext cx="0" cy="0"/>
+          <a:chOff x="0" y="0"/>
+          <a:chExt cx="0" cy="0"/>
+        </a:xfrm>
+      </p:grpSpPr>
       <p:sp>
         <p:nvSpPr>
           <p:cNvPr id="2" name="Rectangle 1"/>
@@ -17282,6 +17461,7 @@
           <a:lstStyle/>
           <a:p>
             <a:pPr algn="ctr"/>
+            <a:endParaRPr/>
           </a:p>
         </p:txBody>
       </p:sp>
@@ -17325,6 +17505,7 @@
           <a:lstStyle/>
           <a:p>
             <a:pPr algn="ctr"/>
+            <a:endParaRPr/>
           </a:p>
         </p:txBody>
       </p:sp>
@@ -17345,7 +17526,7 @@
           <a:noFill/>
         </p:spPr>
         <p:txBody>
-          <a:bodyPr wrap="square" lIns="0" rIns="0" tIns="0" bIns="0">
+          <a:bodyPr wrap="square" lIns="0" tIns="0" rIns="0" bIns="0">
             <a:spAutoFit/>
           </a:bodyPr>
           <a:lstStyle/>
@@ -17379,7 +17560,7 @@
           <a:noFill/>
         </p:spPr>
         <p:txBody>
-          <a:bodyPr wrap="square" lIns="0" rIns="0" tIns="0" bIns="0">
+          <a:bodyPr wrap="square" lIns="0" tIns="0" rIns="0" bIns="0">
             <a:spAutoFit/>
           </a:bodyPr>
           <a:lstStyle/>
@@ -17438,6 +17619,7 @@
           <a:lstStyle/>
           <a:p>
             <a:pPr algn="ctr"/>
+            <a:endParaRPr/>
           </a:p>
         </p:txBody>
       </p:sp>
@@ -17481,6 +17663,7 @@
           <a:lstStyle/>
           <a:p>
             <a:pPr algn="ctr"/>
+            <a:endParaRPr/>
           </a:p>
         </p:txBody>
       </p:sp>
@@ -17501,7 +17684,7 @@
           <a:noFill/>
         </p:spPr>
         <p:txBody>
-          <a:bodyPr wrap="square" lIns="0" rIns="0" tIns="0" bIns="0" anchor="ctr">
+          <a:bodyPr wrap="square" lIns="0" tIns="0" rIns="0" bIns="0" anchor="ctr">
             <a:spAutoFit/>
           </a:bodyPr>
           <a:lstStyle/>
@@ -17536,7 +17719,7 @@
           <a:noFill/>
         </p:spPr>
         <p:txBody>
-          <a:bodyPr wrap="square" lIns="0" rIns="0" tIns="0" bIns="0">
+          <a:bodyPr wrap="square" lIns="0" tIns="0" rIns="0" bIns="0">
             <a:spAutoFit/>
           </a:bodyPr>
           <a:lstStyle/>
@@ -17571,7 +17754,7 @@
           <a:noFill/>
         </p:spPr>
         <p:txBody>
-          <a:bodyPr wrap="square" lIns="0" rIns="0" tIns="0" bIns="0">
+          <a:bodyPr wrap="square" lIns="0" tIns="0" rIns="0" bIns="0">
             <a:spAutoFit/>
           </a:bodyPr>
           <a:lstStyle/>
@@ -17606,7 +17789,7 @@
           <a:noFill/>
         </p:spPr>
         <p:txBody>
-          <a:bodyPr wrap="square" lIns="0" rIns="0" tIns="0" bIns="0">
+          <a:bodyPr wrap="square" lIns="0" tIns="0" rIns="0" bIns="0">
             <a:spAutoFit/>
           </a:bodyPr>
           <a:lstStyle/>
@@ -17641,7 +17824,7 @@
           <a:noFill/>
         </p:spPr>
         <p:txBody>
-          <a:bodyPr wrap="square" lIns="0" rIns="0" tIns="0" bIns="0">
+          <a:bodyPr wrap="square" lIns="0" tIns="0" rIns="0" bIns="0">
             <a:spAutoFit/>
           </a:bodyPr>
           <a:lstStyle/>
@@ -17676,7 +17859,7 @@
           <a:noFill/>
         </p:spPr>
         <p:txBody>
-          <a:bodyPr wrap="square" lIns="0" rIns="0" tIns="0" bIns="0">
+          <a:bodyPr wrap="square" lIns="0" tIns="0" rIns="0" bIns="0">
             <a:spAutoFit/>
           </a:bodyPr>
           <a:lstStyle/>
@@ -17711,7 +17894,7 @@
           <a:noFill/>
         </p:spPr>
         <p:txBody>
-          <a:bodyPr wrap="square" lIns="0" rIns="0" tIns="0" bIns="0">
+          <a:bodyPr wrap="square" lIns="0" tIns="0" rIns="0" bIns="0">
             <a:spAutoFit/>
           </a:bodyPr>
           <a:lstStyle/>
@@ -17746,7 +17929,7 @@
           <a:noFill/>
         </p:spPr>
         <p:txBody>
-          <a:bodyPr wrap="square" lIns="0" rIns="0" tIns="0" bIns="0">
+          <a:bodyPr wrap="square" lIns="0" tIns="0" rIns="0" bIns="0">
             <a:spAutoFit/>
           </a:bodyPr>
           <a:lstStyle/>
@@ -17781,7 +17964,7 @@
           <a:noFill/>
         </p:spPr>
         <p:txBody>
-          <a:bodyPr wrap="square" lIns="0" rIns="0" tIns="0" bIns="0">
+          <a:bodyPr wrap="square" lIns="0" tIns="0" rIns="0" bIns="0">
             <a:spAutoFit/>
           </a:bodyPr>
           <a:lstStyle/>
@@ -17841,6 +18024,7 @@
           <a:lstStyle/>
           <a:p>
             <a:pPr algn="ctr"/>
+            <a:endParaRPr/>
           </a:p>
         </p:txBody>
       </p:sp>
@@ -17861,7 +18045,7 @@
           <a:noFill/>
         </p:spPr>
         <p:txBody>
-          <a:bodyPr wrap="square" lIns="0" rIns="0" tIns="0" bIns="0">
+          <a:bodyPr wrap="square" lIns="0" tIns="0" rIns="0" bIns="0">
             <a:spAutoFit/>
           </a:bodyPr>
           <a:lstStyle/>
@@ -17918,6 +18102,7 @@
           <a:lstStyle/>
           <a:p>
             <a:pPr algn="ctr"/>
+            <a:endParaRPr/>
           </a:p>
         </p:txBody>
       </p:sp>
@@ -17938,7 +18123,7 @@
           <a:noFill/>
         </p:spPr>
         <p:txBody>
-          <a:bodyPr wrap="square" lIns="0" rIns="0" tIns="0" bIns="0">
+          <a:bodyPr wrap="square" lIns="0" tIns="0" rIns="0" bIns="0">
             <a:spAutoFit/>
           </a:bodyPr>
           <a:lstStyle/>
@@ -17972,7 +18157,7 @@
           <a:noFill/>
         </p:spPr>
         <p:txBody>
-          <a:bodyPr wrap="square" lIns="0" rIns="0" tIns="0" bIns="0">
+          <a:bodyPr wrap="square" lIns="0" tIns="0" rIns="0" bIns="0">
             <a:spAutoFit/>
           </a:bodyPr>
           <a:lstStyle/>
@@ -18029,6 +18214,7 @@
           <a:lstStyle/>
           <a:p>
             <a:pPr algn="ctr"/>
+            <a:endParaRPr/>
           </a:p>
         </p:txBody>
       </p:sp>
@@ -18049,7 +18235,7 @@
           <a:noFill/>
         </p:spPr>
         <p:txBody>
-          <a:bodyPr wrap="square" lIns="0" rIns="0" tIns="0" bIns="0">
+          <a:bodyPr wrap="square" lIns="0" tIns="0" rIns="0" bIns="0">
             <a:spAutoFit/>
           </a:bodyPr>
           <a:lstStyle/>
@@ -18083,7 +18269,7 @@
           <a:noFill/>
         </p:spPr>
         <p:txBody>
-          <a:bodyPr wrap="square" lIns="0" rIns="0" tIns="0" bIns="0">
+          <a:bodyPr wrap="square" lIns="0" tIns="0" rIns="0" bIns="0">
             <a:spAutoFit/>
           </a:bodyPr>
           <a:lstStyle/>
@@ -18140,6 +18326,7 @@
           <a:lstStyle/>
           <a:p>
             <a:pPr algn="ctr"/>
+            <a:endParaRPr/>
           </a:p>
         </p:txBody>
       </p:sp>
@@ -18160,7 +18347,7 @@
           <a:noFill/>
         </p:spPr>
         <p:txBody>
-          <a:bodyPr wrap="square" lIns="0" rIns="0" tIns="0" bIns="0">
+          <a:bodyPr wrap="square" lIns="0" tIns="0" rIns="0" bIns="0">
             <a:spAutoFit/>
           </a:bodyPr>
           <a:lstStyle/>
@@ -18194,7 +18381,7 @@
           <a:noFill/>
         </p:spPr>
         <p:txBody>
-          <a:bodyPr wrap="square" lIns="0" rIns="0" tIns="0" bIns="0">
+          <a:bodyPr wrap="square" lIns="0" tIns="0" rIns="0" bIns="0">
             <a:spAutoFit/>
           </a:bodyPr>
           <a:lstStyle/>
@@ -18251,6 +18438,7 @@
           <a:lstStyle/>
           <a:p>
             <a:pPr algn="ctr"/>
+            <a:endParaRPr/>
           </a:p>
         </p:txBody>
       </p:sp>
@@ -18271,7 +18459,7 @@
           <a:noFill/>
         </p:spPr>
         <p:txBody>
-          <a:bodyPr wrap="square" lIns="0" rIns="0" tIns="0" bIns="0">
+          <a:bodyPr wrap="square" lIns="0" tIns="0" rIns="0" bIns="0">
             <a:spAutoFit/>
           </a:bodyPr>
           <a:lstStyle/>
@@ -18305,7 +18493,7 @@
           <a:noFill/>
         </p:spPr>
         <p:txBody>
-          <a:bodyPr wrap="square" lIns="0" rIns="0" tIns="0" bIns="0">
+          <a:bodyPr wrap="square" lIns="0" tIns="0" rIns="0" bIns="0">
             <a:spAutoFit/>
           </a:bodyPr>
           <a:lstStyle/>
@@ -18317,7 +18505,7 @@
                 </a:solidFill>
                 <a:latin typeface="Calibri"/>
               </a:rPr>
-              <a:t>Built MVP solo in months, not years</a:t>
+              <a:t>Shipped MVP + web app + AI Copilot solo (~5 weeks, May 2026)</a:t>
             </a:r>
           </a:p>
         </p:txBody>
@@ -18364,6 +18552,7 @@
           <a:lstStyle/>
           <a:p>
             <a:pPr algn="ctr"/>
+            <a:endParaRPr/>
           </a:p>
         </p:txBody>
       </p:sp>
@@ -18384,7 +18573,7 @@
           <a:noFill/>
         </p:spPr>
         <p:txBody>
-          <a:bodyPr wrap="square" lIns="0" rIns="0" tIns="0" bIns="0">
+          <a:bodyPr wrap="square" lIns="0" tIns="0" rIns="0" bIns="0">
             <a:spAutoFit/>
           </a:bodyPr>
           <a:lstStyle/>
@@ -18441,6 +18630,7 @@
           <a:lstStyle/>
           <a:p>
             <a:pPr algn="ctr"/>
+            <a:endParaRPr/>
           </a:p>
         </p:txBody>
       </p:sp>
@@ -18461,7 +18651,7 @@
           <a:noFill/>
         </p:spPr>
         <p:txBody>
-          <a:bodyPr wrap="square" lIns="0" rIns="0" tIns="0" bIns="0" anchor="ctr">
+          <a:bodyPr wrap="square" lIns="0" tIns="0" rIns="0" bIns="0" anchor="ctr">
             <a:spAutoFit/>
           </a:bodyPr>
           <a:lstStyle/>
@@ -18496,7 +18686,7 @@
           <a:noFill/>
         </p:spPr>
         <p:txBody>
-          <a:bodyPr wrap="square" lIns="0" rIns="0" tIns="0" bIns="0" anchor="ctr">
+          <a:bodyPr wrap="square" lIns="0" tIns="0" rIns="0" bIns="0" anchor="ctr">
             <a:spAutoFit/>
           </a:bodyPr>
           <a:lstStyle/>
@@ -18553,6 +18743,7 @@
           <a:lstStyle/>
           <a:p>
             <a:pPr algn="ctr"/>
+            <a:endParaRPr/>
           </a:p>
         </p:txBody>
       </p:sp>
@@ -18573,7 +18764,7 @@
           <a:noFill/>
         </p:spPr>
         <p:txBody>
-          <a:bodyPr wrap="square" lIns="0" rIns="0" tIns="0" bIns="0" anchor="ctr">
+          <a:bodyPr wrap="square" lIns="0" tIns="0" rIns="0" bIns="0" anchor="ctr">
             <a:spAutoFit/>
           </a:bodyPr>
           <a:lstStyle/>
@@ -18608,7 +18799,7 @@
           <a:noFill/>
         </p:spPr>
         <p:txBody>
-          <a:bodyPr wrap="square" lIns="0" rIns="0" tIns="0" bIns="0" anchor="ctr">
+          <a:bodyPr wrap="square" lIns="0" tIns="0" rIns="0" bIns="0" anchor="ctr">
             <a:spAutoFit/>
           </a:bodyPr>
           <a:lstStyle/>
@@ -18665,6 +18856,7 @@
           <a:lstStyle/>
           <a:p>
             <a:pPr algn="ctr"/>
+            <a:endParaRPr/>
           </a:p>
         </p:txBody>
       </p:sp>
@@ -18685,7 +18877,7 @@
           <a:noFill/>
         </p:spPr>
         <p:txBody>
-          <a:bodyPr wrap="square" lIns="0" rIns="0" tIns="0" bIns="0" anchor="ctr">
+          <a:bodyPr wrap="square" lIns="0" tIns="0" rIns="0" bIns="0" anchor="ctr">
             <a:spAutoFit/>
           </a:bodyPr>
           <a:lstStyle/>
@@ -18720,7 +18912,7 @@
           <a:noFill/>
         </p:spPr>
         <p:txBody>
-          <a:bodyPr wrap="square" lIns="0" rIns="0" tIns="0" bIns="0" anchor="ctr">
+          <a:bodyPr wrap="square" lIns="0" tIns="0" rIns="0" bIns="0" anchor="ctr">
             <a:spAutoFit/>
           </a:bodyPr>
           <a:lstStyle/>
@@ -18777,6 +18969,7 @@
           <a:lstStyle/>
           <a:p>
             <a:pPr algn="ctr"/>
+            <a:endParaRPr/>
           </a:p>
         </p:txBody>
       </p:sp>
@@ -18797,7 +18990,7 @@
           <a:noFill/>
         </p:spPr>
         <p:txBody>
-          <a:bodyPr wrap="square" lIns="0" rIns="0" tIns="0" bIns="0" anchor="ctr">
+          <a:bodyPr wrap="square" lIns="0" tIns="0" rIns="0" bIns="0" anchor="ctr">
             <a:spAutoFit/>
           </a:bodyPr>
           <a:lstStyle/>
@@ -18832,7 +19025,7 @@
           <a:noFill/>
         </p:spPr>
         <p:txBody>
-          <a:bodyPr wrap="square" lIns="0" rIns="0" tIns="0" bIns="0" anchor="ctr">
+          <a:bodyPr wrap="square" lIns="0" tIns="0" rIns="0" bIns="0" anchor="ctr">
             <a:spAutoFit/>
           </a:bodyPr>
           <a:lstStyle/>
@@ -18866,7 +19059,7 @@
           <a:noFill/>
         </p:spPr>
         <p:txBody>
-          <a:bodyPr wrap="square" lIns="0" rIns="0" tIns="0" bIns="0">
+          <a:bodyPr wrap="square" lIns="0" tIns="0" rIns="0" bIns="0">
             <a:spAutoFit/>
           </a:bodyPr>
           <a:lstStyle/>
@@ -18900,7 +19093,7 @@
           <a:noFill/>
         </p:spPr>
         <p:txBody>
-          <a:bodyPr wrap="square" lIns="0" rIns="0" tIns="0" bIns="0">
+          <a:bodyPr wrap="square" lIns="0" tIns="0" rIns="0" bIns="0">
             <a:spAutoFit/>
           </a:bodyPr>
           <a:lstStyle/>

</xml_diff>